<commit_message>
Replace em dashes in workshop materials
Keep the copy in plain punctuation so it reads like workshop notes, not generated prose.
</commit_message>
<xml_diff>
--- a/snowtooth-rules.pptx
+++ b/snowtooth-rules.pptx
@@ -114,26 +114,26 @@
   <p:extLst>
     <p:ext uri="{521415D9-36F7-43E2-AB2F-B90AF26B5E84}">
       <p14:sectionLst xmlns:p14="http://schemas.microsoft.com/office/powerpoint/2010/main">
-        <p14:section name="Open" id="{ddac2e38-beff-0746-4796-a937c8a50cdd}">
+        <p14:section name="Open" id="{5181837c-1ba2-5933-3fc0-f13b31223eb4}">
           <p14:sldIdLst>
             <p14:sldId id="256"/>
             <p14:sldId id="257"/>
             <p14:sldId id="258"/>
           </p14:sldIdLst>
         </p14:section>
-        <p14:section name="Demo" id="{3b240369-f0d1-9ca9-eb62-c8bfdc68689a}">
+        <p14:section name="Demo" id="{d8e401ef-c1ea-ae26-7563-795076600d6f}">
           <p14:sldIdLst>
             <p14:sldId id="259"/>
             <p14:sldId id="260"/>
             <p14:sldId id="261"/>
           </p14:sldIdLst>
         </p14:section>
-        <p14:section name="Lab" id="{83118690-f563-6d8a-2b82-d06c0a396589}">
+        <p14:section name="Lab" id="{2c5eedd4-b4e7-8fce-8b94-404673dbfce6}">
           <p14:sldIdLst>
             <p14:sldId id="262"/>
           </p14:sldIdLst>
         </p14:section>
-        <p14:section name="Takeaway" id="{3353815b-3de5-cd33-e97b-a04f8d75bfc0}">
+        <p14:section name="Takeaway" id="{d72478e5-d403-fff7-d5e4-4b54cd7229d1}">
           <p14:sldIdLst>
             <p14:sldId id="263"/>
           </p14:sldIdLst>
@@ -542,7 +542,7 @@
           <a:p>
             <a:r>
               <a:rPr lang="en-US" dirty="0"/>
-              <a:t>I'm Eve. I train engineering teams on this for a living — React, GraphQL, and now Cursor. This is a 15-minute slice of the first thing I teach when a team gets seats: stop re-explaining yourselves in chat.
+              <a:t>I'm Eve. I train engineering teams on this for a living: React, GraphQL, and now Cursor. This is a 15-minute slice of the first thing I teach when a team gets seats: stop re-explaining yourselves in chat.
 Snowtooth is a fake ski resort I've used for years, so nobody spends the hour learning a domain. The lift board is the stand-in for your app.
 Why this open: I want them looking at a real artifact, not a feature list. If I open Cursor settings first, they remember a menu. If I start from the annoyance, they remember the habit.</a:t>
             </a:r>
@@ -634,7 +634,7 @@
               <a:rPr lang="en-US" dirty="0"/>
               <a:t>The pattern I see every week: someone pastes the same correction into chat. It works. They close the tab. Tomorrow the agent does it again. A teammate never saw it.
 That's not a prompting skill issue. The team has no memory.
-Start from the actual annoyance, not the Rules UI. LiftBoard is still on a raw fetch on purpose — leftover code the agent will copy. I will not fix it in this session. Rules are for next time.
+Start from the actual annoyance, not the Rules UI. LiftBoard is still on a raw fetch on purpose. Leftover code the agent will copy. I will not fix it in this session. Rules are for next time.
 Real-world translation: your company bought Cursor seats. Some people are power users. Most are pasting the same sentence.</a:t>
             </a:r>
             <a:endParaRPr lang="en-US" dirty="0"/>
@@ -818,7 +818,7 @@
 LiftBoard still fetches the public API and hand-styles status. That leftover is intentional, so the agent has a bad example to copy. StatusBadge and getTrails() already exist. The model just doesn't know they're the law.
 If it unexpectedly uses the client, backup prompt: 'Add a night-skiing trails list.' If that also succeeds, narrate: sometimes the model guesses. The rule is how we stop guessing.
 Why the miss comes first: a clean success doesn't teach. Contrast does.
-Then restore the Checkpoint — Cursor's restore, not git checkout — and we write the rule.</a:t>
+Then restore the Checkpoint (Cursor's restore, not git checkout) and we write the rule.</a:t>
             </a:r>
             <a:endParaRPr lang="en-US" dirty="0"/>
           </a:p>
@@ -907,7 +907,7 @@
             <a:r>
               <a:rPr lang="en-US" dirty="0"/>
               <a:t>I write this live with /create-rule, then we read the file together. That's the Cursor-native path, and they still learn to read an .mdc.
-Description so the agent knows when. One do, one don't, in real code. Point at @lib/snowtooth.ts instead of pasting the client — pasted copies go stale. That's a real Cursor best practice, not a style preference.
+Description so the agent knows when. One do, one don't, in real code. Point at @lib/snowtooth.ts instead of pasting the client. Pasted copies go stale. That's a real Cursor best practice, not a style preference.
 Live-demo choice: alwaysApply true so it actually fires in the next two minutes. Apply Intelligently is the right default at work. I will not gamble a 15-minute session on the model deciding. We name that tradeoff on the last slide.
 Two concerns in one file is a smell. I still do one file so they finish. I'd split on a 45-minute version.</a:t>
             </a:r>
@@ -997,11 +997,11 @@
           <a:p>
             <a:r>
               <a:rPr lang="en-US" dirty="0"/>
-              <a:t>New chat. Same prompt. It should call getTrails(). I point at the rule pill so they see why — it was in the prompt this time, not because the last chat remembered.
+              <a:t>New chat. Same prompt. It should call getTrails(). I point at the rule pill so they see why: it was in the prompt this time, not because the last chat remembered.
 Then I commit. That is the whole topic. A rule on your laptop is a user preference. A rule in git is how the team gets the same behavior tomorrow.
 If it fails: check the pill, confirm alwaysApply, one more new chat. Then flip to the checkpoint branch and play the 90-second recording.
 Tip I say with my hands on the product: restore a Checkpoint to undo the first panel. Don't git checkout during the demo unless the agent goes off the rails.
-Optional if time: 'Add the grooming report too.' Same client. I skip it if we're late — the trails panel is the whole story.</a:t>
+Optional if time: 'Add the grooming report too.' Same client. I skip it if we're late. The trails panel is the whole story.</a:t>
             </a:r>
             <a:endParaRPr lang="en-US" dirty="0"/>
           </a:p>
@@ -1090,7 +1090,7 @@
             <a:r>
               <a:rPr lang="en-US" dirty="0"/>
               <a:t>They do the marketing copy rule. Same loop, different convention. I do not live-debug everyone. Fell behind? git stash &amp;&amp; git checkout checkpoint.
-handout.md is in .cursorignore so the agent can't read the answers. That's a real teaching move, not a cute extra — mention it when they ask about learner gaps.
+handout.md is in .cursorignore so the agent can't read the answers. That's a real teaching move, not a cute extra. Mention it when they ask about learner gaps.
 Done: a fresh chat produces an Open Runs panel with StatusBadge. That's the assessment for outcomes 2 and 3.
 I will not fix LiftBoard, and I will not have them update TrailsPanel. Rules are for the next thing they ask for.
 Stretch is in the handout if someone finishes early: replace the rule with 'Write good, consistent code' and rerun. That's how you feel a vague rule.</a:t>
@@ -1182,7 +1182,7 @@
             <a:r>
               <a:rPr lang="en-US" dirty="0"/>
               <a:t>This is the only slide I want them photographing.
-Walk the table fast. The security line matters: AI guidance is not a control. The Tab line is the gotcha from the docs — rules do not apply to Tab or Cmd+K. Don't let them think the rule is broken when completions still say trails.
+Walk the table fast. The security line matters: AI guidance is not a control. The Tab line is the gotcha from the docs: rules do not apply to Tab or Cmd+K. Don't let them think the rule is broken when completions still say trails.
 Skills get one sentence: use a skill when you keep explaining a whole routine, not a sentence. That's why skills wait for a later session.
 How you know it worked: in the room, Open Runs + StatusBadge. Next week, a rule lands in the repo, and the next feature request isn't preceded by 'remember, we say runs.'</a:t>
             </a:r>
@@ -2045,7 +2045,7 @@
                 <a:ea typeface="Arial" pitchFamily="34" charset="-122"/>
                 <a:cs typeface="Arial" pitchFamily="34" charset="-120"/>
               </a:rPr>
-              <a:t>“Remember — we don't fetch in components. Use the data client.”</a:t>
+              <a:t>“Remember, we don't fetch in components. Use the data client.”</a:t>
             </a:r>
             <a:endParaRPr lang="en-US" sz="2200" dirty="0"/>
           </a:p>
@@ -3561,7 +3561,7 @@
                 <a:ea typeface="Courier New" pitchFamily="34" charset="-122"/>
                 <a:cs typeface="Courier New" pitchFamily="34" charset="-120"/>
               </a:rPr>
-              <a:t>New chat to test a rule. Staying in the thread cheats — the model still has your correction.</a:t>
+              <a:t>New chat to test a rule. Staying in the thread cheats. The model still has your correction.</a:t>
             </a:r>
             <a:endParaRPr lang="en-US" sz="1200" dirty="0"/>
           </a:p>

</xml_diff>

<commit_message>
Clarify the three workshop branches
main is the student start, checkpoint is the mid-point after the demo, and complete is the finished board. The build-together replaces the silent lab.
</commit_message>
<xml_diff>
--- a/snowtooth-rules.pptx
+++ b/snowtooth-rules.pptx
@@ -114,26 +114,26 @@
   <p:extLst>
     <p:ext uri="{521415D9-36F7-43E2-AB2F-B90AF26B5E84}">
       <p14:sectionLst xmlns:p14="http://schemas.microsoft.com/office/powerpoint/2010/main">
-        <p14:section name="Open" id="{5181837c-1ba2-5933-3fc0-f13b31223eb4}">
+        <p14:section name="Open" id="{fbafba08-32b3-0b11-64a6-ab95e5968fa6}">
           <p14:sldIdLst>
             <p14:sldId id="256"/>
             <p14:sldId id="257"/>
             <p14:sldId id="258"/>
           </p14:sldIdLst>
         </p14:section>
-        <p14:section name="Demo" id="{d8e401ef-c1ea-ae26-7563-795076600d6f}">
+        <p14:section name="Demo" id="{fcb0f5e4-a216-aeb3-625d-ddbcba0c2f6f}">
           <p14:sldIdLst>
             <p14:sldId id="259"/>
             <p14:sldId id="260"/>
             <p14:sldId id="261"/>
           </p14:sldIdLst>
         </p14:section>
-        <p14:section name="Lab" id="{2c5eedd4-b4e7-8fce-8b94-404673dbfce6}">
+        <p14:section name="Build" id="{45f0a304-f30b-ac95-1e2b-d1428ab3bbb2}">
           <p14:sldIdLst>
             <p14:sldId id="262"/>
           </p14:sldIdLst>
         </p14:section>
-        <p14:section name="Takeaway" id="{d72478e5-d403-fff7-d5e4-4b54cd7229d1}">
+        <p14:section name="Takeaway" id="{b7f6991c-370d-b737-a2a4-581f15bb98a7}">
           <p14:sldIdLst>
             <p14:sldId id="263"/>
           </p14:sldIdLst>
@@ -1089,11 +1089,9 @@
           <a:p>
             <a:r>
               <a:rPr lang="en-US" dirty="0"/>
-              <a:t>They do the marketing copy rule. Same loop, different convention. I do not live-debug everyone. Fell behind? git stash &amp;&amp; git checkout checkpoint.
-handout.md is in .cursorignore so the agent can't read the answers. That's a real teaching move, not a cute extra. Mention it when they ask about learner gaps.
-Done: a fresh chat produces an Open Runs panel with StatusBadge. That's the assessment for outcomes 2 and 3.
-I will not fix LiftBoard, and I will not have them update TrailsPanel. Rules are for the next thing they ask for.
-Stretch is in the handout if someone finishes early: replace the rule with 'Write good, consistent code' and rerun. That's how you feel a vague rule.</a:t>
+              <a:t>Same loop, copy instead of data. I still drive. They name the do and don't, then I write the rule with their words.
+Two minutes, not a silent lab. If we are late, stop after they name the convention. The handout is what they take home.
+handout.md is in .cursorignore so the agent can't read it. Stretch lives in the handout for after class.</a:t>
             </a:r>
             <a:endParaRPr lang="en-US" dirty="0"/>
           </a:p>
@@ -4920,7 +4918,7 @@
                 <a:ea typeface="Arial" pitchFamily="34" charset="-122"/>
                 <a:cs typeface="Arial" pitchFamily="34" charset="-120"/>
               </a:rPr>
-              <a:t>Your turn. Marketing just emailed.</a:t>
+              <a:t>Build this together.</a:t>
             </a:r>
             <a:endParaRPr lang="en-US" sz="2600" dirty="0"/>
           </a:p>
@@ -5057,7 +5055,7 @@
                 <a:ea typeface="Arial" pitchFamily="34" charset="-122"/>
                 <a:cs typeface="Arial" pitchFamily="34" charset="-120"/>
               </a:rPr>
-              <a:t>New chat. The prompt is in handout.md. Read the diff.</a:t>
+              <a:t>Same prompt as the handout. Read the miss together.</a:t>
             </a:r>
             <a:endParaRPr lang="en-US" sz="1600" dirty="0"/>
           </a:p>
@@ -5135,7 +5133,7 @@
                 <a:ea typeface="Arial" pitchFamily="34" charset="-122"/>
                 <a:cs typeface="Arial" pitchFamily="34" charset="-120"/>
               </a:rPr>
-              <a:t>Restore the Checkpoint. /create-rule, or write snowtooth-copy.mdc.</a:t>
+              <a:t>You name the do and don't. We write the rule.</a:t>
             </a:r>
             <a:endParaRPr lang="en-US" sz="1600" dirty="0"/>
           </a:p>
@@ -5213,7 +5211,7 @@
                 <a:ea typeface="Arial" pitchFamily="34" charset="-122"/>
                 <a:cs typeface="Arial" pitchFamily="34" charset="-120"/>
               </a:rPr>
-              <a:t>New chat. Same prompt. Check the diff again. Commit the rule.</a:t>
+              <a:t>New chat if we have time. Same test as before.</a:t>
             </a:r>
             <a:endParaRPr lang="en-US" sz="1600" dirty="0"/>
           </a:p>
@@ -5266,7 +5264,7 @@
                 <a:ea typeface="Courier New" pitchFamily="34" charset="-122"/>
                 <a:cs typeface="Courier New" pitchFamily="34" charset="-120"/>
               </a:rPr>
-              <a:t>handout.md is in .cursorignore, so the agent can't read the lab.</a:t>
+              <a:t>You drive. They talk. The handout is the take-home.</a:t>
             </a:r>
             <a:endParaRPr lang="en-US" sz="1200" dirty="0"/>
           </a:p>

</xml_diff>

<commit_message>
Drop the Monday-problem wording
Say what actually happens: you keep typing the same correction. The closer is just take it with you.
</commit_message>
<xml_diff>
--- a/snowtooth-rules.pptx
+++ b/snowtooth-rules.pptx
@@ -114,26 +114,26 @@
   <p:extLst>
     <p:ext uri="{521415D9-36F7-43E2-AB2F-B90AF26B5E84}">
       <p14:sectionLst xmlns:p14="http://schemas.microsoft.com/office/powerpoint/2010/main">
-        <p14:section name="Open" id="{fbafba08-32b3-0b11-64a6-ab95e5968fa6}">
+        <p14:section name="Open" id="{e4567297-626a-462d-5269-4ab06ca70dd2}">
           <p14:sldIdLst>
             <p14:sldId id="256"/>
             <p14:sldId id="257"/>
             <p14:sldId id="258"/>
           </p14:sldIdLst>
         </p14:section>
-        <p14:section name="Demo" id="{fcb0f5e4-a216-aeb3-625d-ddbcba0c2f6f}">
+        <p14:section name="Demo" id="{3f065ac2-16ae-696d-ad9b-0335cb01de35}">
           <p14:sldIdLst>
             <p14:sldId id="259"/>
             <p14:sldId id="260"/>
             <p14:sldId id="261"/>
           </p14:sldIdLst>
         </p14:section>
-        <p14:section name="Build" id="{45f0a304-f30b-ac95-1e2b-d1428ab3bbb2}">
+        <p14:section name="Build" id="{089476ed-a4e9-c436-803b-0fffdaa6d58b}">
           <p14:sldIdLst>
             <p14:sldId id="262"/>
           </p14:sldIdLst>
         </p14:section>
-        <p14:section name="Takeaway" id="{b7f6991c-370d-b737-a2a4-581f15bb98a7}">
+        <p14:section name="Takeaway" id="{102fb0b6-8e0e-0e2e-765c-fd533c6bafb1}">
           <p14:sldIdLst>
             <p14:sldId id="263"/>
           </p14:sldIdLst>
@@ -1984,7 +1984,7 @@
                 <a:ea typeface="Arial" pitchFamily="34" charset="-122"/>
                 <a:cs typeface="Arial" pitchFamily="34" charset="-120"/>
               </a:rPr>
-              <a:t>You've already typed this twice this week</a:t>
+              <a:t>You keep typing the same correction</a:t>
             </a:r>
             <a:endParaRPr lang="en-US" sz="2600" dirty="0"/>
           </a:p>
@@ -5917,7 +5917,7 @@
                 <a:ea typeface="Arial" pitchFamily="34" charset="-122"/>
                 <a:cs typeface="Arial" pitchFamily="34" charset="-120"/>
               </a:rPr>
-              <a:t>Monday: pick one thing you've said twice. Make it a rule before standup.</a:t>
+              <a:t>Pick one thing you've already had to say twice. Make it a rule.</a:t>
             </a:r>
             <a:endParaRPr lang="en-US" sz="1600" dirty="0"/>
           </a:p>

</xml_diff>

<commit_message>
Match the deck to the rewritten workshop notes
Co-authored-by: Cursor <cursoragent@cursor.com>
</commit_message>
<xml_diff>
--- a/snowtooth-rules.pptx
+++ b/snowtooth-rules.pptx
@@ -114,26 +114,26 @@
   <p:extLst>
     <p:ext uri="{521415D9-36F7-43E2-AB2F-B90AF26B5E84}">
       <p14:sectionLst xmlns:p14="http://schemas.microsoft.com/office/powerpoint/2010/main">
-        <p14:section name="Open" id="{e4567297-626a-462d-5269-4ab06ca70dd2}">
+        <p14:section name="Open" id="{a689c11f-a542-d0d2-495c-132a541ecc27}">
           <p14:sldIdLst>
             <p14:sldId id="256"/>
             <p14:sldId id="257"/>
             <p14:sldId id="258"/>
           </p14:sldIdLst>
         </p14:section>
-        <p14:section name="Demo" id="{3f065ac2-16ae-696d-ad9b-0335cb01de35}">
+        <p14:section name="Demo" id="{b968514d-8ec5-44de-8656-0eff34953812}">
           <p14:sldIdLst>
             <p14:sldId id="259"/>
             <p14:sldId id="260"/>
             <p14:sldId id="261"/>
           </p14:sldIdLst>
         </p14:section>
-        <p14:section name="Build" id="{089476ed-a4e9-c436-803b-0fffdaa6d58b}">
+        <p14:section name="Build" id="{cfca0c40-c534-8b17-3e92-20a814fb3fe7}">
           <p14:sldIdLst>
             <p14:sldId id="262"/>
           </p14:sldIdLst>
         </p14:section>
-        <p14:section name="Takeaway" id="{102fb0b6-8e0e-0e2e-765c-fd533c6bafb1}">
+        <p14:section name="Takeaway" id="{808046c3-fbd0-876a-48f0-3f7f05e80cd5}">
           <p14:sldIdLst>
             <p14:sldId id="263"/>
           </p14:sldIdLst>
@@ -1091,7 +1091,7 @@
               <a:rPr lang="en-US" dirty="0"/>
               <a:t>Same loop, copy instead of data. I still drive. They name the do and don't, then I write the rule with their words.
 Two minutes, not a silent lab. If we are late, stop after they name the convention. The handout is what they take home.
-handout.md is in .cursorignore so the agent can't read it. Stretch lives in the handout for after class.</a:t>
+handout.md is in .cursorignore so the agent can't read it. The extra credit lives in the handout for after class.</a:t>
             </a:r>
             <a:endParaRPr lang="en-US" dirty="0"/>
           </a:p>
@@ -5375,7 +5375,7 @@
                 <a:ea typeface="Arial" pitchFamily="34" charset="-122"/>
                 <a:cs typeface="Arial" pitchFamily="34" charset="-120"/>
               </a:rPr>
-              <a:t>Take this with you</a:t>
+              <a:t>Should it be a rule?</a:t>
             </a:r>
             <a:endParaRPr lang="en-US" sz="2600" dirty="0"/>
           </a:p>
@@ -5434,7 +5434,7 @@
                 <a:ea typeface="Arial" pitchFamily="34" charset="-122"/>
                 <a:cs typeface="Arial" pitchFamily="34" charset="-120"/>
               </a:rPr>
-              <a:t>You've said it twice</a:t>
+              <a:t>You've had to say it twice</a:t>
             </a:r>
             <a:endParaRPr lang="en-US" sz="1500" dirty="0"/>
           </a:p>
@@ -5512,7 +5512,7 @@
                 <a:ea typeface="Arial" pitchFamily="34" charset="-122"/>
                 <a:cs typeface="Arial" pitchFamily="34" charset="-120"/>
               </a:rPr>
-              <a:t>A linter or test can check it</a:t>
+              <a:t>A linter or test could check it</a:t>
             </a:r>
             <a:endParaRPr lang="en-US" sz="1500" dirty="0"/>
           </a:p>
@@ -5551,7 +5551,7 @@
                 <a:ea typeface="Arial" pitchFamily="34" charset="-122"/>
                 <a:cs typeface="Arial" pitchFamily="34" charset="-120"/>
               </a:rPr>
-              <a:t>Use the linter or test</a:t>
+              <a:t>Use the linter or test instead</a:t>
             </a:r>
             <a:endParaRPr lang="en-US" sz="1500" dirty="0"/>
           </a:p>
@@ -5688,7 +5688,7 @@
                 <a:ea typeface="Arial" pitchFamily="34" charset="-122"/>
                 <a:cs typeface="Arial" pitchFamily="34" charset="-120"/>
               </a:rPr>
-              <a:t>It must always be on</a:t>
+              <a:t>It should always be on</a:t>
             </a:r>
             <a:endParaRPr lang="en-US" sz="1500" dirty="0"/>
           </a:p>
@@ -5727,7 +5727,7 @@
                 <a:ea typeface="Arial" pitchFamily="34" charset="-122"/>
                 <a:cs typeface="Arial" pitchFamily="34" charset="-120"/>
               </a:rPr>
-              <a:t>alwaysApply: true</a:t>
+              <a:t>Set alwaysApply: true</a:t>
             </a:r>
             <a:endParaRPr lang="en-US" sz="1500" dirty="0"/>
           </a:p>
@@ -5825,7 +5825,7 @@
                 <a:ea typeface="Arial" pitchFamily="34" charset="-122"/>
                 <a:cs typeface="Arial" pitchFamily="34" charset="-120"/>
               </a:rPr>
-              <a:t>Never a rule alone</a:t>
+              <a:t>Don't rely on a rule alone</a:t>
             </a:r>
             <a:endParaRPr lang="en-US" sz="1500" dirty="0"/>
           </a:p>
@@ -5878,7 +5878,7 @@
                 <a:ea typeface="Courier New" pitchFamily="34" charset="-122"/>
                 <a:cs typeface="Courier New" pitchFamily="34" charset="-120"/>
               </a:rPr>
-              <a:t>Rules do not apply to Tab. Completions may still say trails.</a:t>
+              <a:t>Rules don't apply to Tab, so completions might still say trails.</a:t>
             </a:r>
             <a:endParaRPr lang="en-US" sz="1200" dirty="0"/>
           </a:p>

</xml_diff>

<commit_message>
Add rule-size and @-reference notes to the anatomy slide
Co-authored-by: Cursor <cursoragent@cursor.com>
</commit_message>
<xml_diff>
--- a/snowtooth-rules.pptx
+++ b/snowtooth-rules.pptx
@@ -1050,7 +1050,7 @@
           <a:p>
             <a:pPr/>
             <a:r>
-              <a:t>The description tells the agent when the rule applies. The do and don't are written as real code. And we point at @lib/snowtooth.ts instead of pasting the client in, because pasted copies go stale. That last part is a Cursor best practice, not just my preference.</a:t>
+              <a:t>The description tells the agent when the rule applies. The do and don't are written as real code. And we point at @lib/snowtooth.ts instead of pasting the client in, because pasted copies go stale. That last part is a Cursor best practice, not just my preference. An @ reference isn't pasted into the prompt: the agent reads the file only when it decides it needs to. So anything that must always apply goes in the rule's own text, which is why the do and don't are written out and @lib/snowtooth.ts is only a pointer.</a:t>
             </a:r>
           </a:p>
           <a:p>
@@ -1068,7 +1068,7 @@
           <a:p>
             <a:pPr/>
             <a:r>
-              <a:t>Putting two concerns in one rule file would be a smell. In a 45-minute version I'd talk about how to split rules up. Today we keep it to one small file so everyone finishes.</a:t>
+              <a:t>Cursor's docs recommend keeping each rule small and focused: one convention per rule, under 500 lines. That's why the data rule and the copy rule are separate files. In a 45-minute version I'd talk more about how to split rules up.</a:t>
             </a:r>
           </a:p>
         </p:txBody>

</xml_diff>

<commit_message>
Add a challenge slide and light mountain touches to the deck
Co-authored-by: Cursor <cursoragent@cursor.com>
</commit_message>
<xml_diff>
--- a/snowtooth-rules.pptx
+++ b/snowtooth-rules.pptx
@@ -17,6 +17,7 @@
     <p:sldId id="262" r:id="rId14"/>
     <p:sldId id="263" r:id="rId15"/>
     <p:sldId id="264" r:id="rId16"/>
+    <p:sldId id="265" r:id="rId17"/>
   </p:sldIdLst>
   <p:sldSz cx="9144000" cy="5143500"/>
   <p:notesSz cx="6858000" cy="9144000"/>
@@ -587,6 +588,94 @@
 </p:notes>
 </file>
 
+<file path=ppt/notesSlides/notesSlide10.xml><?xml version="1.0" encoding="utf-8"?>
+<p:notes xmlns:a="http://schemas.openxmlformats.org/drawingml/2006/main" xmlns:r="http://schemas.openxmlformats.org/officeDocument/2006/relationships" xmlns:p="http://schemas.openxmlformats.org/presentationml/2006/main" xmlns:m="http://schemas.openxmlformats.org/officeDocument/2006/math" xmlns:a14="http://schemas.microsoft.com/office/drawing/2010/main" showMasterSp="1" showMasterPhAnim="1">
+  <p:cSld>
+    <p:spTree>
+      <p:nvGrpSpPr>
+        <p:cNvPr id="1" name=""/>
+        <p:cNvGrpSpPr/>
+        <p:nvPr/>
+      </p:nvGrpSpPr>
+      <p:grpSpPr>
+        <a:xfrm>
+          <a:off x="0" y="0"/>
+          <a:ext cx="0" cy="0"/>
+          <a:chOff x="0" y="0"/>
+          <a:chExt cx="0" cy="0"/>
+        </a:xfrm>
+      </p:grpSpPr>
+      <p:sp>
+        <p:nvSpPr>
+          <p:cNvPr id="168" name="Shape 168"/>
+          <p:cNvSpPr/>
+          <p:nvPr>
+            <p:ph type="sldImg"/>
+          </p:nvPr>
+        </p:nvSpPr>
+        <p:spPr>
+          <a:prstGeom prst="rect">
+            <a:avLst/>
+          </a:prstGeom>
+        </p:spPr>
+        <p:txBody>
+          <a:bodyPr/>
+          <a:lstStyle/>
+          <a:p>
+            <a:pPr/>
+          </a:p>
+        </p:txBody>
+      </p:sp>
+      <p:sp>
+        <p:nvSpPr>
+          <p:cNvPr id="169" name="Shape 169"/>
+          <p:cNvSpPr/>
+          <p:nvPr>
+            <p:ph type="body" sz="quarter" idx="1"/>
+          </p:nvPr>
+        </p:nvSpPr>
+        <p:spPr>
+          <a:prstGeom prst="rect">
+            <a:avLst/>
+          </a:prstGeom>
+        </p:spPr>
+        <p:txBody>
+          <a:bodyPr/>
+          <a:lstStyle/>
+          <a:p>
+            <a:pPr/>
+            <a:r>
+              <a:t>This is the last stop, and it's how I know the session worked. Everyone writes one rule on their own, for something they've had to tell an agent twice at work or something in Snowtooth, and pastes it into chat.</a:t>
+            </a:r>
+          </a:p>
+          <a:p>
+            <a:pPr/>
+          </a:p>
+          <a:p>
+            <a:pPr/>
+            <a:r>
+              <a:t>If anyone's stuck: every time a guest sees should use formatMountainTime() from lib/time.ts, and nothing enforces that yet. The grooming prompt on the slide shows whether their rule works.</a:t>
+            </a:r>
+          </a:p>
+          <a:p>
+            <a:pPr/>
+          </a:p>
+          <a:p>
+            <a:pPr/>
+            <a:r>
+              <a:t>If the rules people post have a description, a do and a don't, and a pointer to a real file, they can do this without me. I read a couple out loud before we wrap up.</a:t>
+            </a:r>
+          </a:p>
+        </p:txBody>
+      </p:sp>
+    </p:spTree>
+  </p:cSld>
+  <p:clrMapOvr>
+    <a:masterClrMapping/>
+  </p:clrMapOvr>
+</p:notes>
+</file>
+
 <file path=ppt/notesSlides/notesSlide2.xml><?xml version="1.0" encoding="utf-8"?>
 <p:notes xmlns:a="http://schemas.openxmlformats.org/drawingml/2006/main" xmlns:r="http://schemas.openxmlformats.org/officeDocument/2006/relationships" xmlns:p="http://schemas.openxmlformats.org/presentationml/2006/main" xmlns:m="http://schemas.openxmlformats.org/officeDocument/2006/math" xmlns:a14="http://schemas.microsoft.com/office/drawing/2010/main" showMasterSp="1" showMasterPhAnim="1">
   <p:cSld>
@@ -1351,15 +1440,6 @@
             <a:pPr/>
             <a:r>
               <a:t>Skills get one sentence: a skill is for when you keep explaining a whole routine, not a single sentence. That's why they get their own session.</a:t>
-            </a:r>
-          </a:p>
-          <a:p>
-            <a:pPr/>
-          </a:p>
-          <a:p>
-            <a:pPr/>
-            <a:r>
-              <a:t>Then the challenge, which is how I know the session worked. Everyone writes one rule on their own, for something they've had to tell an agent twice at work or something in Snowtooth, and pastes it into chat. If anyone's stuck: every time a guest sees should use formatMountainTime() from lib/time.ts. If the rules people post have a description, a do and a don't, and a pointer to a real file, they can do this without me.</a:t>
             </a:r>
           </a:p>
         </p:txBody>
@@ -2510,6 +2590,285 @@
       </p:grpSpPr>
       <p:sp>
         <p:nvSpPr>
+          <p:cNvPr id="950" name="mountain-back-1" descr="Decorative mountain"/>
+          <p:cNvSpPr/>
+          <p:nvPr/>
+        </p:nvSpPr>
+        <p:spPr>
+          <a:xfrm>
+            <a:off x="0" y="4274820"/>
+            <a:ext cx="3840480" cy="868680"/>
+          </a:xfrm>
+          <a:prstGeom prst="triangle">
+            <a:avLst>
+              <a:gd name="adj" fmla="val 40000"/>
+            </a:avLst>
+          </a:prstGeom>
+          <a:solidFill>
+            <a:srgbClr val="262626"/>
+          </a:solidFill>
+          <a:ln>
+            <a:noFill/>
+          </a:ln>
+        </p:spPr>
+        <p:txBody>
+          <a:bodyPr/>
+          <a:lstStyle/>
+          <a:p>
+            <a:endParaRPr lang="en-US"/>
+          </a:p>
+        </p:txBody>
+      </p:sp>
+      <p:sp>
+        <p:nvSpPr>
+          <p:cNvPr id="951" name="mountain-back-2" descr="Decorative mountain"/>
+          <p:cNvSpPr/>
+          <p:nvPr/>
+        </p:nvSpPr>
+        <p:spPr>
+          <a:xfrm>
+            <a:off x="2194560" y="3909060"/>
+            <a:ext cx="4572000" cy="1234440"/>
+          </a:xfrm>
+          <a:prstGeom prst="triangle">
+            <a:avLst>
+              <a:gd name="adj" fmla="val 50000"/>
+            </a:avLst>
+          </a:prstGeom>
+          <a:solidFill>
+            <a:srgbClr val="262626"/>
+          </a:solidFill>
+          <a:ln>
+            <a:noFill/>
+          </a:ln>
+        </p:spPr>
+        <p:txBody>
+          <a:bodyPr/>
+          <a:lstStyle/>
+          <a:p>
+            <a:endParaRPr lang="en-US"/>
+          </a:p>
+        </p:txBody>
+      </p:sp>
+      <p:sp>
+        <p:nvSpPr>
+          <p:cNvPr id="952" name="mountain-back-3" descr="Decorative mountain"/>
+          <p:cNvSpPr/>
+          <p:nvPr/>
+        </p:nvSpPr>
+        <p:spPr>
+          <a:xfrm>
+            <a:off x="5303520" y="4183380"/>
+            <a:ext cx="3840480" cy="960120"/>
+          </a:xfrm>
+          <a:prstGeom prst="triangle">
+            <a:avLst>
+              <a:gd name="adj" fmla="val 55000"/>
+            </a:avLst>
+          </a:prstGeom>
+          <a:solidFill>
+            <a:srgbClr val="262626"/>
+          </a:solidFill>
+          <a:ln>
+            <a:noFill/>
+          </a:ln>
+        </p:spPr>
+        <p:txBody>
+          <a:bodyPr/>
+          <a:lstStyle/>
+          <a:p>
+            <a:endParaRPr lang="en-US"/>
+          </a:p>
+        </p:txBody>
+      </p:sp>
+      <p:sp>
+        <p:nvSpPr>
+          <p:cNvPr id="953" name="snowcap-1" descr="Decorative snowcap"/>
+          <p:cNvSpPr/>
+          <p:nvPr/>
+        </p:nvSpPr>
+        <p:spPr>
+          <a:xfrm>
+            <a:off x="1167505" y="4274820"/>
+            <a:ext cx="921715" cy="208483"/>
+          </a:xfrm>
+          <a:prstGeom prst="triangle">
+            <a:avLst>
+              <a:gd name="adj" fmla="val 40000"/>
+            </a:avLst>
+          </a:prstGeom>
+          <a:solidFill>
+            <a:srgbClr val="5C5C5C"/>
+          </a:solidFill>
+          <a:ln>
+            <a:noFill/>
+          </a:ln>
+        </p:spPr>
+        <p:txBody>
+          <a:bodyPr/>
+          <a:lstStyle/>
+          <a:p>
+            <a:endParaRPr lang="en-US"/>
+          </a:p>
+        </p:txBody>
+      </p:sp>
+      <p:sp>
+        <p:nvSpPr>
+          <p:cNvPr id="954" name="snowcap-2" descr="Decorative snowcap"/>
+          <p:cNvSpPr/>
+          <p:nvPr/>
+        </p:nvSpPr>
+        <p:spPr>
+          <a:xfrm>
+            <a:off x="3931920" y="3909060"/>
+            <a:ext cx="1097280" cy="296265"/>
+          </a:xfrm>
+          <a:prstGeom prst="triangle">
+            <a:avLst>
+              <a:gd name="adj" fmla="val 50000"/>
+            </a:avLst>
+          </a:prstGeom>
+          <a:solidFill>
+            <a:srgbClr val="5C5C5C"/>
+          </a:solidFill>
+          <a:ln>
+            <a:noFill/>
+          </a:ln>
+        </p:spPr>
+        <p:txBody>
+          <a:bodyPr/>
+          <a:lstStyle/>
+          <a:p>
+            <a:endParaRPr lang="en-US"/>
+          </a:p>
+        </p:txBody>
+      </p:sp>
+      <p:sp>
+        <p:nvSpPr>
+          <p:cNvPr id="955" name="snowcap-3" descr="Decorative snowcap"/>
+          <p:cNvSpPr/>
+          <p:nvPr/>
+        </p:nvSpPr>
+        <p:spPr>
+          <a:xfrm>
+            <a:off x="6908840" y="4183380"/>
+            <a:ext cx="921715" cy="230428"/>
+          </a:xfrm>
+          <a:prstGeom prst="triangle">
+            <a:avLst>
+              <a:gd name="adj" fmla="val 55000"/>
+            </a:avLst>
+          </a:prstGeom>
+          <a:solidFill>
+            <a:srgbClr val="5C5C5C"/>
+          </a:solidFill>
+          <a:ln>
+            <a:noFill/>
+          </a:ln>
+        </p:spPr>
+        <p:txBody>
+          <a:bodyPr/>
+          <a:lstStyle/>
+          <a:p>
+            <a:endParaRPr lang="en-US"/>
+          </a:p>
+        </p:txBody>
+      </p:sp>
+      <p:sp>
+        <p:nvSpPr>
+          <p:cNvPr id="956" name="mountain-front-1" descr="Decorative mountain"/>
+          <p:cNvSpPr/>
+          <p:nvPr/>
+        </p:nvSpPr>
+        <p:spPr>
+          <a:xfrm>
+            <a:off x="0" y="4640580"/>
+            <a:ext cx="4206240" cy="502920"/>
+          </a:xfrm>
+          <a:prstGeom prst="triangle">
+            <a:avLst>
+              <a:gd name="adj" fmla="val 35000"/>
+            </a:avLst>
+          </a:prstGeom>
+          <a:solidFill>
+            <a:srgbClr val="171717"/>
+          </a:solidFill>
+          <a:ln>
+            <a:noFill/>
+          </a:ln>
+        </p:spPr>
+        <p:txBody>
+          <a:bodyPr/>
+          <a:lstStyle/>
+          <a:p>
+            <a:endParaRPr lang="en-US"/>
+          </a:p>
+        </p:txBody>
+      </p:sp>
+      <p:sp>
+        <p:nvSpPr>
+          <p:cNvPr id="957" name="mountain-front-2" descr="Decorative mountain"/>
+          <p:cNvSpPr/>
+          <p:nvPr/>
+        </p:nvSpPr>
+        <p:spPr>
+          <a:xfrm>
+            <a:off x="2743200" y="4485132"/>
+            <a:ext cx="4572000" cy="658368"/>
+          </a:xfrm>
+          <a:prstGeom prst="triangle">
+            <a:avLst>
+              <a:gd name="adj" fmla="val 55000"/>
+            </a:avLst>
+          </a:prstGeom>
+          <a:solidFill>
+            <a:srgbClr val="171717"/>
+          </a:solidFill>
+          <a:ln>
+            <a:noFill/>
+          </a:ln>
+        </p:spPr>
+        <p:txBody>
+          <a:bodyPr/>
+          <a:lstStyle/>
+          <a:p>
+            <a:endParaRPr lang="en-US"/>
+          </a:p>
+        </p:txBody>
+      </p:sp>
+      <p:sp>
+        <p:nvSpPr>
+          <p:cNvPr id="958" name="mountain-front-3" descr="Decorative mountain"/>
+          <p:cNvSpPr/>
+          <p:nvPr/>
+        </p:nvSpPr>
+        <p:spPr>
+          <a:xfrm>
+            <a:off x="5669280" y="4686300"/>
+            <a:ext cx="3474720" cy="457200"/>
+          </a:xfrm>
+          <a:prstGeom prst="triangle">
+            <a:avLst>
+              <a:gd name="adj" fmla="val 45000"/>
+            </a:avLst>
+          </a:prstGeom>
+          <a:solidFill>
+            <a:srgbClr val="171717"/>
+          </a:solidFill>
+          <a:ln>
+            <a:noFill/>
+          </a:ln>
+        </p:spPr>
+        <p:txBody>
+          <a:bodyPr/>
+          <a:lstStyle/>
+          <a:p>
+            <a:endParaRPr lang="en-US"/>
+          </a:p>
+        </p:txBody>
+      </p:sp>
+      <p:sp>
+        <p:nvSpPr>
           <p:cNvPr id="36" name="Text 0"/>
           <p:cNvSpPr txBox="1"/>
           <p:nvPr>
@@ -2630,6 +2989,709 @@
             <a:pPr/>
             <a:r>
               <a:t>15 min   Eve Porcello   a rule the team can use tomorrow</a:t>
+            </a:r>
+          </a:p>
+        </p:txBody>
+      </p:sp>
+    </p:spTree>
+  </p:cSld>
+  <p:clrMapOvr>
+    <a:masterClrMapping/>
+  </p:clrMapOvr>
+  <p:transition xmlns:p14="http://schemas.microsoft.com/office/powerpoint/2010/main" spd="med" advClick="1"/>
+</p:sld>
+</file>
+
+<file path=ppt/slides/slide10.xml><?xml version="1.0" encoding="utf-8"?>
+<p:sld xmlns:a="http://schemas.openxmlformats.org/drawingml/2006/main" xmlns:r="http://schemas.openxmlformats.org/officeDocument/2006/relationships" xmlns:p="http://schemas.openxmlformats.org/presentationml/2006/main" xmlns:m="http://schemas.openxmlformats.org/officeDocument/2006/math" xmlns:a14="http://schemas.microsoft.com/office/drawing/2010/main" showMasterSp="1" showMasterPhAnim="1">
+  <p:cSld>
+    <p:spTree>
+      <p:nvGrpSpPr>
+        <p:cNvPr id="1" name=""/>
+        <p:cNvGrpSpPr/>
+        <p:nvPr/>
+      </p:nvGrpSpPr>
+      <p:grpSpPr>
+        <a:xfrm>
+          <a:off x="0" y="0"/>
+          <a:ext cx="0" cy="0"/>
+          <a:chOff x="0" y="0"/>
+          <a:chExt cx="0" cy="0"/>
+        </a:xfrm>
+      </p:grpSpPr>
+      <p:sp>
+        <p:nvSpPr>
+          <p:cNvPr id="950" name="mountain-back-1" descr="Decorative mountain"/>
+          <p:cNvSpPr/>
+          <p:nvPr/>
+        </p:nvSpPr>
+        <p:spPr>
+          <a:xfrm>
+            <a:off x="0" y="4518051"/>
+            <a:ext cx="3840480" cy="625449"/>
+          </a:xfrm>
+          <a:prstGeom prst="triangle">
+            <a:avLst>
+              <a:gd name="adj" fmla="val 40000"/>
+            </a:avLst>
+          </a:prstGeom>
+          <a:solidFill>
+            <a:srgbClr val="262626"/>
+          </a:solidFill>
+          <a:ln>
+            <a:noFill/>
+          </a:ln>
+        </p:spPr>
+        <p:txBody>
+          <a:bodyPr/>
+          <a:lstStyle/>
+          <a:p>
+            <a:endParaRPr lang="en-US"/>
+          </a:p>
+        </p:txBody>
+      </p:sp>
+      <p:sp>
+        <p:nvSpPr>
+          <p:cNvPr id="951" name="mountain-back-2" descr="Decorative mountain"/>
+          <p:cNvSpPr/>
+          <p:nvPr/>
+        </p:nvSpPr>
+        <p:spPr>
+          <a:xfrm>
+            <a:off x="2194560" y="4254704"/>
+            <a:ext cx="4572000" cy="888796"/>
+          </a:xfrm>
+          <a:prstGeom prst="triangle">
+            <a:avLst>
+              <a:gd name="adj" fmla="val 50000"/>
+            </a:avLst>
+          </a:prstGeom>
+          <a:solidFill>
+            <a:srgbClr val="262626"/>
+          </a:solidFill>
+          <a:ln>
+            <a:noFill/>
+          </a:ln>
+        </p:spPr>
+        <p:txBody>
+          <a:bodyPr/>
+          <a:lstStyle/>
+          <a:p>
+            <a:endParaRPr lang="en-US"/>
+          </a:p>
+        </p:txBody>
+      </p:sp>
+      <p:sp>
+        <p:nvSpPr>
+          <p:cNvPr id="952" name="mountain-back-3" descr="Decorative mountain"/>
+          <p:cNvSpPr/>
+          <p:nvPr/>
+        </p:nvSpPr>
+        <p:spPr>
+          <a:xfrm>
+            <a:off x="5303520" y="4452214"/>
+            <a:ext cx="3840480" cy="691286"/>
+          </a:xfrm>
+          <a:prstGeom prst="triangle">
+            <a:avLst>
+              <a:gd name="adj" fmla="val 55000"/>
+            </a:avLst>
+          </a:prstGeom>
+          <a:solidFill>
+            <a:srgbClr val="262626"/>
+          </a:solidFill>
+          <a:ln>
+            <a:noFill/>
+          </a:ln>
+        </p:spPr>
+        <p:txBody>
+          <a:bodyPr/>
+          <a:lstStyle/>
+          <a:p>
+            <a:endParaRPr lang="en-US"/>
+          </a:p>
+        </p:txBody>
+      </p:sp>
+      <p:sp>
+        <p:nvSpPr>
+          <p:cNvPr id="953" name="snowcap-1" descr="Decorative snowcap"/>
+          <p:cNvSpPr/>
+          <p:nvPr/>
+        </p:nvSpPr>
+        <p:spPr>
+          <a:xfrm>
+            <a:off x="1167505" y="4518051"/>
+            <a:ext cx="921715" cy="150107"/>
+          </a:xfrm>
+          <a:prstGeom prst="triangle">
+            <a:avLst>
+              <a:gd name="adj" fmla="val 40000"/>
+            </a:avLst>
+          </a:prstGeom>
+          <a:solidFill>
+            <a:srgbClr val="5C5C5C"/>
+          </a:solidFill>
+          <a:ln>
+            <a:noFill/>
+          </a:ln>
+        </p:spPr>
+        <p:txBody>
+          <a:bodyPr/>
+          <a:lstStyle/>
+          <a:p>
+            <a:endParaRPr lang="en-US"/>
+          </a:p>
+        </p:txBody>
+      </p:sp>
+      <p:sp>
+        <p:nvSpPr>
+          <p:cNvPr id="954" name="snowcap-2" descr="Decorative snowcap"/>
+          <p:cNvSpPr/>
+          <p:nvPr/>
+        </p:nvSpPr>
+        <p:spPr>
+          <a:xfrm>
+            <a:off x="3931920" y="4254704"/>
+            <a:ext cx="1097280" cy="213311"/>
+          </a:xfrm>
+          <a:prstGeom prst="triangle">
+            <a:avLst>
+              <a:gd name="adj" fmla="val 50000"/>
+            </a:avLst>
+          </a:prstGeom>
+          <a:solidFill>
+            <a:srgbClr val="5C5C5C"/>
+          </a:solidFill>
+          <a:ln>
+            <a:noFill/>
+          </a:ln>
+        </p:spPr>
+        <p:txBody>
+          <a:bodyPr/>
+          <a:lstStyle/>
+          <a:p>
+            <a:endParaRPr lang="en-US"/>
+          </a:p>
+        </p:txBody>
+      </p:sp>
+      <p:sp>
+        <p:nvSpPr>
+          <p:cNvPr id="955" name="snowcap-3" descr="Decorative snowcap"/>
+          <p:cNvSpPr/>
+          <p:nvPr/>
+        </p:nvSpPr>
+        <p:spPr>
+          <a:xfrm>
+            <a:off x="6908840" y="4452214"/>
+            <a:ext cx="921715" cy="165908"/>
+          </a:xfrm>
+          <a:prstGeom prst="triangle">
+            <a:avLst>
+              <a:gd name="adj" fmla="val 55000"/>
+            </a:avLst>
+          </a:prstGeom>
+          <a:solidFill>
+            <a:srgbClr val="5C5C5C"/>
+          </a:solidFill>
+          <a:ln>
+            <a:noFill/>
+          </a:ln>
+        </p:spPr>
+        <p:txBody>
+          <a:bodyPr/>
+          <a:lstStyle/>
+          <a:p>
+            <a:endParaRPr lang="en-US"/>
+          </a:p>
+        </p:txBody>
+      </p:sp>
+      <p:sp>
+        <p:nvSpPr>
+          <p:cNvPr id="956" name="mountain-front-1" descr="Decorative mountain"/>
+          <p:cNvSpPr/>
+          <p:nvPr/>
+        </p:nvSpPr>
+        <p:spPr>
+          <a:xfrm>
+            <a:off x="0" y="4781398"/>
+            <a:ext cx="4206240" cy="362102"/>
+          </a:xfrm>
+          <a:prstGeom prst="triangle">
+            <a:avLst>
+              <a:gd name="adj" fmla="val 35000"/>
+            </a:avLst>
+          </a:prstGeom>
+          <a:solidFill>
+            <a:srgbClr val="171717"/>
+          </a:solidFill>
+          <a:ln>
+            <a:noFill/>
+          </a:ln>
+        </p:spPr>
+        <p:txBody>
+          <a:bodyPr/>
+          <a:lstStyle/>
+          <a:p>
+            <a:endParaRPr lang="en-US"/>
+          </a:p>
+        </p:txBody>
+      </p:sp>
+      <p:sp>
+        <p:nvSpPr>
+          <p:cNvPr id="957" name="mountain-front-2" descr="Decorative mountain"/>
+          <p:cNvSpPr/>
+          <p:nvPr/>
+        </p:nvSpPr>
+        <p:spPr>
+          <a:xfrm>
+            <a:off x="2743200" y="4669476"/>
+            <a:ext cx="4572000" cy="474024"/>
+          </a:xfrm>
+          <a:prstGeom prst="triangle">
+            <a:avLst>
+              <a:gd name="adj" fmla="val 55000"/>
+            </a:avLst>
+          </a:prstGeom>
+          <a:solidFill>
+            <a:srgbClr val="171717"/>
+          </a:solidFill>
+          <a:ln>
+            <a:noFill/>
+          </a:ln>
+        </p:spPr>
+        <p:txBody>
+          <a:bodyPr/>
+          <a:lstStyle/>
+          <a:p>
+            <a:endParaRPr lang="en-US"/>
+          </a:p>
+        </p:txBody>
+      </p:sp>
+      <p:sp>
+        <p:nvSpPr>
+          <p:cNvPr id="958" name="mountain-front-3" descr="Decorative mountain"/>
+          <p:cNvSpPr/>
+          <p:nvPr/>
+        </p:nvSpPr>
+        <p:spPr>
+          <a:xfrm>
+            <a:off x="5669280" y="4814316"/>
+            <a:ext cx="3474720" cy="329184"/>
+          </a:xfrm>
+          <a:prstGeom prst="triangle">
+            <a:avLst>
+              <a:gd name="adj" fmla="val 45000"/>
+            </a:avLst>
+          </a:prstGeom>
+          <a:solidFill>
+            <a:srgbClr val="171717"/>
+          </a:solidFill>
+          <a:ln>
+            <a:noFill/>
+          </a:ln>
+        </p:spPr>
+        <p:txBody>
+          <a:bodyPr/>
+          <a:lstStyle/>
+          <a:p>
+            <a:endParaRPr lang="en-US"/>
+          </a:p>
+        </p:txBody>
+      </p:sp>
+      <p:sp>
+        <p:nvSpPr>
+          <p:cNvPr id="138" name="Text 0"/>
+          <p:cNvSpPr txBox="1"/>
+          <p:nvPr>
+            <p:ph type="title"/>
+          </p:nvPr>
+        </p:nvSpPr>
+        <p:spPr>
+          <a:xfrm>
+            <a:off x="457200" y="292608"/>
+            <a:ext cx="8229600" cy="530353"/>
+          </a:xfrm>
+          <a:prstGeom prst="rect">
+            <a:avLst/>
+          </a:prstGeom>
+        </p:spPr>
+        <p:txBody>
+          <a:bodyPr lIns="0" tIns="0" rIns="0" bIns="0" anchor="ctr"/>
+          <a:lstStyle/>
+          <a:p>
+            <a:pPr/>
+            <a:r>
+              <a:t>Your challenge</a:t>
+            </a:r>
+          </a:p>
+        </p:txBody>
+      </p:sp>
+      <p:sp>
+        <p:nvSpPr>
+          <p:cNvPr id="139" name="marketing-card"/>
+          <p:cNvSpPr/>
+          <p:nvPr/>
+        </p:nvSpPr>
+        <p:spPr>
+          <a:xfrm>
+            <a:off x="457200" y="960119"/>
+            <a:ext cx="8229600" cy="658369"/>
+          </a:xfrm>
+          <a:prstGeom prst="rect">
+            <a:avLst/>
+          </a:prstGeom>
+          <a:solidFill>
+            <a:srgbClr val="141414"/>
+          </a:solidFill>
+          <a:ln w="12700">
+            <a:miter lim="400000"/>
+          </a:ln>
+        </p:spPr>
+        <p:txBody>
+          <a:bodyPr lIns="45719" rIns="45719"/>
+          <a:lstStyle/>
+          <a:p>
+            <a:pPr/>
+          </a:p>
+        </p:txBody>
+      </p:sp>
+      <p:sp>
+        <p:nvSpPr>
+          <p:cNvPr id="140" name="marketing-copy"/>
+          <p:cNvSpPr txBox="1"/>
+          <p:nvPr/>
+        </p:nvSpPr>
+        <p:spPr>
+          <a:xfrm>
+            <a:off x="640079" y="1178327"/>
+            <a:ext cx="7863842" cy="221954"/>
+          </a:xfrm>
+          <a:prstGeom prst="rect">
+            <a:avLst/>
+          </a:prstGeom>
+          <a:ln w="12700">
+            <a:miter lim="400000"/>
+          </a:ln>
+          <a:extLst>
+            <a:ext uri="{C572A759-6A51-4108-AA02-DFA0A04FC94B}">
+              <ma14:wrappingTextBoxFlag xmlns:ma14="http://schemas.microsoft.com/office/mac/drawingml/2011/main" val="1"/>
+            </a:ext>
+          </a:extLst>
+        </p:spPr>
+        <p:txBody>
+          <a:bodyPr lIns="0" tIns="0" rIns="0" bIns="0" anchor="ctr">
+            <a:spAutoFit/>
+          </a:bodyPr>
+          <a:lstStyle>
+            <a:lvl1pPr>
+              <a:defRPr sz="1600">
+                <a:solidFill>
+                  <a:schemeClr val="accent1"/>
+                </a:solidFill>
+              </a:defRPr>
+            </a:lvl1pPr>
+          </a:lstStyle>
+          <a:p>
+            <a:pPr/>
+            <a:r>
+              <a:t>Write one more rule on your own, then paste it in chat.</a:t>
+            </a:r>
+          </a:p>
+        </p:txBody>
+      </p:sp>
+      <p:sp>
+        <p:nvSpPr>
+          <p:cNvPr id="900" name="trail-1" descr="Green circle: easiest"/>
+          <p:cNvSpPr/>
+          <p:nvPr/>
+        </p:nvSpPr>
+        <p:spPr>
+          <a:xfrm>
+            <a:off x="475487" y="1947671"/>
+            <a:ext cx="182880" cy="182880"/>
+          </a:xfrm>
+          <a:prstGeom prst="ellipse">
+            <a:avLst/>
+          </a:prstGeom>
+          <a:solidFill>
+            <a:srgbClr val="1F9D55"/>
+          </a:solidFill>
+          <a:ln>
+            <a:noFill/>
+          </a:ln>
+        </p:spPr>
+        <p:txBody>
+          <a:bodyPr/>
+          <a:lstStyle/>
+          <a:p>
+            <a:endParaRPr lang="en-US"/>
+          </a:p>
+        </p:txBody>
+      </p:sp>
+      <p:sp>
+        <p:nvSpPr>
+          <p:cNvPr id="142" name="lab-text-01"/>
+          <p:cNvSpPr txBox="1"/>
+          <p:nvPr/>
+        </p:nvSpPr>
+        <p:spPr>
+          <a:xfrm>
+            <a:off x="1051559" y="1928135"/>
+            <a:ext cx="7635242" cy="221954"/>
+          </a:xfrm>
+          <a:prstGeom prst="rect">
+            <a:avLst/>
+          </a:prstGeom>
+          <a:ln w="12700">
+            <a:miter lim="400000"/>
+          </a:ln>
+          <a:extLst>
+            <a:ext uri="{C572A759-6A51-4108-AA02-DFA0A04FC94B}">
+              <ma14:wrappingTextBoxFlag xmlns:ma14="http://schemas.microsoft.com/office/mac/drawingml/2011/main" val="1"/>
+            </a:ext>
+          </a:extLst>
+        </p:spPr>
+        <p:txBody>
+          <a:bodyPr lIns="0" tIns="0" rIns="0" bIns="0" anchor="ctr">
+            <a:spAutoFit/>
+          </a:bodyPr>
+          <a:lstStyle>
+            <a:lvl1pPr>
+              <a:defRPr sz="1600">
+                <a:solidFill>
+                  <a:schemeClr val="accent1"/>
+                </a:solidFill>
+              </a:defRPr>
+            </a:lvl1pPr>
+          </a:lstStyle>
+          <a:p>
+            <a:pPr/>
+            <a:r>
+              <a:t>Pick something you've told an agent twice, at work or in Snowtooth.</a:t>
+            </a:r>
+          </a:p>
+        </p:txBody>
+      </p:sp>
+      <p:sp>
+        <p:nvSpPr>
+          <p:cNvPr id="901" name="trail-2" descr="Blue square: more difficult"/>
+          <p:cNvSpPr/>
+          <p:nvPr/>
+        </p:nvSpPr>
+        <p:spPr>
+          <a:xfrm>
+            <a:off x="484631" y="2578608"/>
+            <a:ext cx="164592" cy="164592"/>
+          </a:xfrm>
+          <a:prstGeom prst="rect">
+            <a:avLst/>
+          </a:prstGeom>
+          <a:solidFill>
+            <a:srgbClr val="3B82F6"/>
+          </a:solidFill>
+          <a:ln>
+            <a:noFill/>
+          </a:ln>
+        </p:spPr>
+        <p:txBody>
+          <a:bodyPr/>
+          <a:lstStyle/>
+          <a:p>
+            <a:endParaRPr lang="en-US"/>
+          </a:p>
+        </p:txBody>
+      </p:sp>
+      <p:sp>
+        <p:nvSpPr>
+          <p:cNvPr id="144" name="lab-text-02"/>
+          <p:cNvSpPr txBox="1"/>
+          <p:nvPr/>
+        </p:nvSpPr>
+        <p:spPr>
+          <a:xfrm>
+            <a:off x="1051559" y="2549927"/>
+            <a:ext cx="7635242" cy="221954"/>
+          </a:xfrm>
+          <a:prstGeom prst="rect">
+            <a:avLst/>
+          </a:prstGeom>
+          <a:ln w="12700">
+            <a:miter lim="400000"/>
+          </a:ln>
+          <a:extLst>
+            <a:ext uri="{C572A759-6A51-4108-AA02-DFA0A04FC94B}">
+              <ma14:wrappingTextBoxFlag xmlns:ma14="http://schemas.microsoft.com/office/mac/drawingml/2011/main" val="1"/>
+            </a:ext>
+          </a:extLst>
+        </p:spPr>
+        <p:txBody>
+          <a:bodyPr lIns="0" tIns="0" rIns="0" bIns="0" anchor="ctr">
+            <a:spAutoFit/>
+          </a:bodyPr>
+          <a:lstStyle>
+            <a:lvl1pPr>
+              <a:defRPr sz="1600">
+                <a:solidFill>
+                  <a:schemeClr val="accent1"/>
+                </a:solidFill>
+              </a:defRPr>
+            </a:lvl1pPr>
+          </a:lstStyle>
+          <a:p>
+            <a:pPr/>
+            <a:r>
+              <a:t>Write the rule: a description, a do, a don't, and an @ pointer.</a:t>
+            </a:r>
+          </a:p>
+        </p:txBody>
+      </p:sp>
+      <p:sp>
+        <p:nvSpPr>
+          <p:cNvPr id="902" name="trail-3" descr="Black diamond: most difficult"/>
+          <p:cNvSpPr/>
+          <p:nvPr/>
+        </p:nvSpPr>
+        <p:spPr>
+          <a:xfrm>
+            <a:off x="461771" y="3177540"/>
+            <a:ext cx="210312" cy="210312"/>
+          </a:xfrm>
+          <a:prstGeom prst="diamond">
+            <a:avLst/>
+          </a:prstGeom>
+          <a:solidFill>
+            <a:srgbClr val="0A0A0A"/>
+          </a:solidFill>
+          <a:ln w="19050">
+            <a:solidFill>
+              <a:srgbClr val="F2F2F2"/>
+            </a:solidFill>
+          </a:ln>
+        </p:spPr>
+        <p:txBody>
+          <a:bodyPr/>
+          <a:lstStyle/>
+          <a:p>
+            <a:endParaRPr lang="en-US"/>
+          </a:p>
+        </p:txBody>
+      </p:sp>
+      <p:sp>
+        <p:nvSpPr>
+          <p:cNvPr id="146" name="lab-text-03"/>
+          <p:cNvSpPr txBox="1"/>
+          <p:nvPr/>
+        </p:nvSpPr>
+        <p:spPr>
+          <a:xfrm>
+            <a:off x="1051559" y="3171719"/>
+            <a:ext cx="7635242" cy="221954"/>
+          </a:xfrm>
+          <a:prstGeom prst="rect">
+            <a:avLst/>
+          </a:prstGeom>
+          <a:ln w="12700">
+            <a:miter lim="400000"/>
+          </a:ln>
+          <a:extLst>
+            <a:ext uri="{C572A759-6A51-4108-AA02-DFA0A04FC94B}">
+              <ma14:wrappingTextBoxFlag xmlns:ma14="http://schemas.microsoft.com/office/mac/drawingml/2011/main" val="1"/>
+            </a:ext>
+          </a:extLst>
+        </p:spPr>
+        <p:txBody>
+          <a:bodyPr lIns="0" tIns="0" rIns="0" bIns="0" anchor="ctr">
+            <a:spAutoFit/>
+          </a:bodyPr>
+          <a:lstStyle>
+            <a:lvl1pPr>
+              <a:defRPr sz="1600">
+                <a:solidFill>
+                  <a:schemeClr val="accent1"/>
+                </a:solidFill>
+              </a:defRPr>
+            </a:lvl1pPr>
+          </a:lstStyle>
+          <a:p>
+            <a:pPr/>
+            <a:r>
+              <a:t>Test it with the same prompt in a new chat, then paste it in chat.</a:t>
+            </a:r>
+          </a:p>
+        </p:txBody>
+      </p:sp>
+      <p:sp>
+        <p:nvSpPr>
+          <p:cNvPr id="147" name="Slide Number Placeholder 0"/>
+          <p:cNvSpPr txBox="1"/>
+          <p:nvPr>
+            <p:ph type="sldNum" sz="quarter" idx="4294967295"/>
+          </p:nvPr>
+        </p:nvSpPr>
+        <p:spPr>
+          <a:xfrm>
+            <a:off x="8549640" y="4828032"/>
+            <a:ext cx="174772" cy="226986"/>
+          </a:xfrm>
+          <a:prstGeom prst="rect">
+            <a:avLst/>
+          </a:prstGeom>
+          <a:extLst>
+            <a:ext uri="{C572A759-6A51-4108-AA02-DFA0A04FC94B}">
+              <ma14:wrappingTextBoxFlag xmlns:ma14="http://schemas.microsoft.com/office/mac/drawingml/2011/main" val="1"/>
+            </a:ext>
+          </a:extLst>
+        </p:spPr>
+        <p:txBody>
+          <a:bodyPr/>
+          <a:lstStyle/>
+          <a:p>
+            <a:pPr/>
+            <a:fld id="{86CB4B4D-7CA3-9044-876B-883B54F8677D}" type="slidenum"/>
+          </a:p>
+        </p:txBody>
+      </p:sp>
+      <p:sp>
+        <p:nvSpPr>
+          <p:cNvPr id="960" name="stuck"/>
+          <p:cNvSpPr txBox="1"/>
+          <p:nvPr/>
+        </p:nvSpPr>
+        <p:spPr>
+          <a:xfrm>
+            <a:off x="457200" y="3639312"/>
+            <a:ext cx="8229600" cy="457200"/>
+          </a:xfrm>
+          <a:prstGeom prst="rect">
+            <a:avLst/>
+          </a:prstGeom>
+          <a:noFill/>
+        </p:spPr>
+        <p:txBody>
+          <a:bodyPr wrap="square" lIns="0" tIns="0" rIns="0" bIns="0" anchor="t"/>
+          <a:lstStyle/>
+          <a:p>
+            <a:r>
+              <a:rPr lang="en-US" sz="1200">
+                <a:solidFill>
+                  <a:srgbClr val="8A8A8A"/>
+                </a:solidFill>
+                <a:latin typeface="Courier New"/>
+                <a:cs typeface="Courier New"/>
+              </a:rPr>
+              <a:t>Stuck? Make every time a guest sees use formatMountainTime().</a:t>
+            </a:r>
+          </a:p>
+          <a:p>
+            <a:r>
+              <a:rPr lang="en-US" sz="1200">
+                <a:solidFill>
+                  <a:srgbClr val="8A8A8A"/>
+                </a:solidFill>
+                <a:latin typeface="Courier New"/>
+                <a:cs typeface="Courier New"/>
+              </a:rPr>
+              <a:t>Test it: “Add a panel that shows when each run was last groomed.”</a:t>
             </a:r>
           </a:p>
         </p:txBody>
@@ -2815,49 +3877,30 @@
       </p:sp>
       <p:sp>
         <p:nvSpPr>
-          <p:cNvPr id="46" name="setup-n-01"/>
-          <p:cNvSpPr txBox="1"/>
-          <p:nvPr/>
-        </p:nvSpPr>
-        <p:spPr>
-          <a:xfrm>
-            <a:off x="457199" y="2467863"/>
-            <a:ext cx="502921" cy="203201"/>
-          </a:xfrm>
-          <a:prstGeom prst="rect">
-            <a:avLst/>
-          </a:prstGeom>
-          <a:ln w="12700">
-            <a:miter lim="400000"/>
-          </a:ln>
-          <a:extLst>
-            <a:ext uri="{C572A759-6A51-4108-AA02-DFA0A04FC94B}">
-              <ma14:wrappingTextBoxFlag xmlns:ma14="http://schemas.microsoft.com/office/mac/drawingml/2011/main" val="1"/>
-            </a:ext>
-          </a:extLst>
-        </p:spPr>
-        <p:txBody>
-          <a:bodyPr lIns="0" tIns="0" rIns="0" bIns="0" anchor="ctr">
-            <a:spAutoFit/>
-          </a:bodyPr>
-          <a:lstStyle>
-            <a:lvl1pPr>
-              <a:defRPr sz="1400">
-                <a:solidFill>
-                  <a:schemeClr val="accent2"/>
-                </a:solidFill>
-                <a:latin typeface="Courier New"/>
-                <a:ea typeface="Courier New"/>
-                <a:cs typeface="Courier New"/>
-                <a:sym typeface="Courier New"/>
-              </a:defRPr>
-            </a:lvl1pPr>
-          </a:lstStyle>
-          <a:p>
-            <a:pPr/>
-            <a:r>
-              <a:t>01</a:t>
-            </a:r>
+          <p:cNvPr id="900" name="trail-1" descr="Green circle: easiest"/>
+          <p:cNvSpPr/>
+          <p:nvPr/>
+        </p:nvSpPr>
+        <p:spPr>
+          <a:xfrm>
+            <a:off x="475487" y="2478023"/>
+            <a:ext cx="182880" cy="182880"/>
+          </a:xfrm>
+          <a:prstGeom prst="ellipse">
+            <a:avLst/>
+          </a:prstGeom>
+          <a:solidFill>
+            <a:srgbClr val="1F9D55"/>
+          </a:solidFill>
+          <a:ln>
+            <a:noFill/>
+          </a:ln>
+        </p:spPr>
+        <p:txBody>
+          <a:bodyPr/>
+          <a:lstStyle/>
+          <a:p>
+            <a:endParaRPr lang="en-US"/>
           </a:p>
         </p:txBody>
       </p:sp>
@@ -2907,49 +3950,30 @@
       </p:sp>
       <p:sp>
         <p:nvSpPr>
-          <p:cNvPr id="48" name="setup-n-02"/>
-          <p:cNvSpPr txBox="1"/>
-          <p:nvPr/>
-        </p:nvSpPr>
-        <p:spPr>
-          <a:xfrm>
-            <a:off x="457199" y="2925063"/>
-            <a:ext cx="502921" cy="203201"/>
-          </a:xfrm>
-          <a:prstGeom prst="rect">
-            <a:avLst/>
-          </a:prstGeom>
-          <a:ln w="12700">
-            <a:miter lim="400000"/>
-          </a:ln>
-          <a:extLst>
-            <a:ext uri="{C572A759-6A51-4108-AA02-DFA0A04FC94B}">
-              <ma14:wrappingTextBoxFlag xmlns:ma14="http://schemas.microsoft.com/office/mac/drawingml/2011/main" val="1"/>
-            </a:ext>
-          </a:extLst>
-        </p:spPr>
-        <p:txBody>
-          <a:bodyPr lIns="0" tIns="0" rIns="0" bIns="0" anchor="ctr">
-            <a:spAutoFit/>
-          </a:bodyPr>
-          <a:lstStyle>
-            <a:lvl1pPr>
-              <a:defRPr sz="1400">
-                <a:solidFill>
-                  <a:schemeClr val="accent2"/>
-                </a:solidFill>
-                <a:latin typeface="Courier New"/>
-                <a:ea typeface="Courier New"/>
-                <a:cs typeface="Courier New"/>
-                <a:sym typeface="Courier New"/>
-              </a:defRPr>
-            </a:lvl1pPr>
-          </a:lstStyle>
-          <a:p>
-            <a:pPr/>
-            <a:r>
-              <a:t>02</a:t>
-            </a:r>
+          <p:cNvPr id="901" name="trail-2" descr="Blue square: more difficult"/>
+          <p:cNvSpPr/>
+          <p:nvPr/>
+        </p:nvSpPr>
+        <p:spPr>
+          <a:xfrm>
+            <a:off x="484631" y="2944367"/>
+            <a:ext cx="164592" cy="164592"/>
+          </a:xfrm>
+          <a:prstGeom prst="rect">
+            <a:avLst/>
+          </a:prstGeom>
+          <a:solidFill>
+            <a:srgbClr val="3B82F6"/>
+          </a:solidFill>
+          <a:ln>
+            <a:noFill/>
+          </a:ln>
+        </p:spPr>
+        <p:txBody>
+          <a:bodyPr/>
+          <a:lstStyle/>
+          <a:p>
+            <a:endParaRPr lang="en-US"/>
           </a:p>
         </p:txBody>
       </p:sp>
@@ -2999,49 +4023,32 @@
       </p:sp>
       <p:sp>
         <p:nvSpPr>
-          <p:cNvPr id="50" name="setup-n-03"/>
-          <p:cNvSpPr txBox="1"/>
-          <p:nvPr/>
-        </p:nvSpPr>
-        <p:spPr>
-          <a:xfrm>
-            <a:off x="457199" y="3382264"/>
-            <a:ext cx="502921" cy="203201"/>
-          </a:xfrm>
-          <a:prstGeom prst="rect">
-            <a:avLst/>
-          </a:prstGeom>
-          <a:ln w="12700">
-            <a:miter lim="400000"/>
-          </a:ln>
-          <a:extLst>
-            <a:ext uri="{C572A759-6A51-4108-AA02-DFA0A04FC94B}">
-              <ma14:wrappingTextBoxFlag xmlns:ma14="http://schemas.microsoft.com/office/mac/drawingml/2011/main" val="1"/>
-            </a:ext>
-          </a:extLst>
-        </p:spPr>
-        <p:txBody>
-          <a:bodyPr lIns="0" tIns="0" rIns="0" bIns="0" anchor="ctr">
-            <a:spAutoFit/>
-          </a:bodyPr>
-          <a:lstStyle>
-            <a:lvl1pPr>
-              <a:defRPr sz="1400">
-                <a:solidFill>
-                  <a:schemeClr val="accent2"/>
-                </a:solidFill>
-                <a:latin typeface="Courier New"/>
-                <a:ea typeface="Courier New"/>
-                <a:cs typeface="Courier New"/>
-                <a:sym typeface="Courier New"/>
-              </a:defRPr>
-            </a:lvl1pPr>
-          </a:lstStyle>
-          <a:p>
-            <a:pPr/>
-            <a:r>
-              <a:t>03</a:t>
-            </a:r>
+          <p:cNvPr id="902" name="trail-3" descr="Black diamond: most difficult"/>
+          <p:cNvSpPr/>
+          <p:nvPr/>
+        </p:nvSpPr>
+        <p:spPr>
+          <a:xfrm>
+            <a:off x="461771" y="3378708"/>
+            <a:ext cx="210312" cy="210312"/>
+          </a:xfrm>
+          <a:prstGeom prst="diamond">
+            <a:avLst/>
+          </a:prstGeom>
+          <a:solidFill>
+            <a:srgbClr val="0A0A0A"/>
+          </a:solidFill>
+          <a:ln w="19050">
+            <a:solidFill>
+              <a:srgbClr val="F2F2F2"/>
+            </a:solidFill>
+          </a:ln>
+        </p:spPr>
+        <p:txBody>
+          <a:bodyPr/>
+          <a:lstStyle/>
+          <a:p>
+            <a:endParaRPr lang="en-US"/>
           </a:p>
         </p:txBody>
       </p:sp>
@@ -7198,50 +8205,6 @@
             <a:pPr/>
             <a:r>
               <a:t>/  Rules don't apply to Tab, so completions might still say trails.</a:t>
-            </a:r>
-          </a:p>
-        </p:txBody>
-      </p:sp>
-      <p:sp>
-        <p:nvSpPr>
-          <p:cNvPr id="166" name="monday"/>
-          <p:cNvSpPr txBox="1"/>
-          <p:nvPr/>
-        </p:nvSpPr>
-        <p:spPr>
-          <a:xfrm>
-            <a:off x="457200" y="3756935"/>
-            <a:ext cx="8229600" cy="221954"/>
-          </a:xfrm>
-          <a:prstGeom prst="rect">
-            <a:avLst/>
-          </a:prstGeom>
-          <a:ln w="12700">
-            <a:miter lim="400000"/>
-          </a:ln>
-          <a:extLst>
-            <a:ext uri="{C572A759-6A51-4108-AA02-DFA0A04FC94B}">
-              <ma14:wrappingTextBoxFlag xmlns:ma14="http://schemas.microsoft.com/office/mac/drawingml/2011/main" val="1"/>
-            </a:ext>
-          </a:extLst>
-        </p:spPr>
-        <p:txBody>
-          <a:bodyPr lIns="0" tIns="0" rIns="0" bIns="0" anchor="ctr">
-            <a:spAutoFit/>
-          </a:bodyPr>
-          <a:lstStyle>
-            <a:lvl1pPr>
-              <a:defRPr sz="1600">
-                <a:solidFill>
-                  <a:schemeClr val="accent1"/>
-                </a:solidFill>
-              </a:defRPr>
-            </a:lvl1pPr>
-          </a:lstStyle>
-          <a:p>
-            <a:pPr/>
-            <a:r>
-              <a:t>Your challenge: write one rule on your own, then paste it in chat.</a:t>
             </a:r>
           </a:p>
         </p:txBody>

</xml_diff>

<commit_message>
Open the deck on a Snowtooth trail map
Co-authored-by: Cursor <cursoragent@cursor.com>
</commit_message>
<xml_diff>
--- a/snowtooth-rules.pptx
+++ b/snowtooth-rules.pptx
@@ -9,6 +9,7 @@
   </p:notesMasterIdLst>
   <p:sldIdLst>
     <p:sldId id="256" r:id="rId8"/>
+    <p:sldId id="266" r:id="rId18"/>
     <p:sldId id="257" r:id="rId9"/>
     <p:sldId id="258" r:id="rId10"/>
     <p:sldId id="259" r:id="rId11"/>
@@ -664,6 +665,94 @@
             <a:pPr/>
             <a:r>
               <a:t>If the rules people post have a description, a do and a don't, and a pointer to a real file, they can do this without me. I read a couple out loud before we wrap up.</a:t>
+            </a:r>
+          </a:p>
+        </p:txBody>
+      </p:sp>
+    </p:spTree>
+  </p:cSld>
+  <p:clrMapOvr>
+    <a:masterClrMapping/>
+  </p:clrMapOvr>
+</p:notes>
+</file>
+
+<file path=ppt/notesSlides/notesSlide11.xml><?xml version="1.0" encoding="utf-8"?>
+<p:notes xmlns:a="http://schemas.openxmlformats.org/drawingml/2006/main" xmlns:r="http://schemas.openxmlformats.org/officeDocument/2006/relationships" xmlns:p="http://schemas.openxmlformats.org/presentationml/2006/main" xmlns:m="http://schemas.openxmlformats.org/officeDocument/2006/math" xmlns:a14="http://schemas.microsoft.com/office/drawing/2010/main" showMasterSp="1" showMasterPhAnim="1">
+  <p:cSld>
+    <p:spTree>
+      <p:nvGrpSpPr>
+        <p:cNvPr id="1" name=""/>
+        <p:cNvGrpSpPr/>
+        <p:nvPr/>
+      </p:nvGrpSpPr>
+      <p:grpSpPr>
+        <a:xfrm>
+          <a:off x="0" y="0"/>
+          <a:ext cx="0" cy="0"/>
+          <a:chOff x="0" y="0"/>
+          <a:chExt cx="0" cy="0"/>
+        </a:xfrm>
+      </p:grpSpPr>
+      <p:sp>
+        <p:nvSpPr>
+          <p:cNvPr id="53" name="Shape 53"/>
+          <p:cNvSpPr/>
+          <p:nvPr>
+            <p:ph type="sldImg"/>
+          </p:nvPr>
+        </p:nvSpPr>
+        <p:spPr>
+          <a:prstGeom prst="rect">
+            <a:avLst/>
+          </a:prstGeom>
+        </p:spPr>
+        <p:txBody>
+          <a:bodyPr/>
+          <a:lstStyle/>
+          <a:p>
+            <a:pPr/>
+          </a:p>
+        </p:txBody>
+      </p:sp>
+      <p:sp>
+        <p:nvSpPr>
+          <p:cNvPr id="54" name="Shape 54"/>
+          <p:cNvSpPr/>
+          <p:nvPr>
+            <p:ph type="body" sz="quarter" idx="1"/>
+          </p:nvPr>
+        </p:nvSpPr>
+        <p:spPr>
+          <a:prstGeom prst="rect">
+            <a:avLst/>
+          </a:prstGeom>
+        </p:spPr>
+        <p:txBody>
+          <a:bodyPr/>
+          <a:lstStyle/>
+          <a:p>
+            <a:pPr/>
+            <a:r>
+              <a:t>Welcome to your first day at Snowtooth Mountain. This is the mountain: eleven lifts and sixty-nine runs. Every name on this map comes from the data in the repo you're about to clone.</a:t>
+            </a:r>
+          </a:p>
+          <a:p>
+            <a:pPr/>
+          </a:p>
+          <a:p>
+            <a:pPr/>
+            <a:r>
+              <a:t>Our team builds the lift board, the screens in the lodge that tell guests which lifts and runs are open. You've got the repo, and you've got Cursor. Cursor is new here too, and nobody has told it how we do things yet.</a:t>
+            </a:r>
+          </a:p>
+          <a:p>
+            <a:pPr/>
+          </a:p>
+          <a:p>
+            <a:pPr/>
+            <a:r>
+              <a:t>Notice I keep saying runs, not trails. That's on purpose, and it comes back later.</a:t>
             </a:r>
           </a:p>
         </p:txBody>
@@ -3705,6 +3794,1379 @@
 </p:sld>
 </file>
 
+<file path=ppt/slides/slide11.xml><?xml version="1.0" encoding="utf-8"?>
+<p:sld xmlns:a="http://schemas.openxmlformats.org/drawingml/2006/main" xmlns:r="http://schemas.openxmlformats.org/officeDocument/2006/relationships" xmlns:p="http://schemas.openxmlformats.org/presentationml/2006/main" xmlns:m="http://schemas.openxmlformats.org/officeDocument/2006/math" xmlns:a14="http://schemas.microsoft.com/office/drawing/2010/main" showMasterSp="1" showMasterPhAnim="1">
+  <p:cSld>
+    <p:spTree>
+      <p:nvGrpSpPr>
+        <p:cNvPr id="1" name=""/>
+        <p:cNvGrpSpPr/>
+        <p:nvPr/>
+      </p:nvGrpSpPr>
+      <p:grpSpPr>
+        <a:xfrm>
+          <a:off x="0" y="0"/>
+          <a:ext cx="0" cy="0"/>
+          <a:chOff x="0" y="0"/>
+          <a:chExt cx="0" cy="0"/>
+        </a:xfrm>
+      </p:grpSpPr>
+      <p:sp>
+        <p:nvSpPr>
+          <p:cNvPr id="42" name="Text 0"/>
+          <p:cNvSpPr txBox="1"/>
+          <p:nvPr>
+            <p:ph type="title"/>
+          </p:nvPr>
+        </p:nvSpPr>
+        <p:spPr>
+          <a:xfrm>
+            <a:off x="457200" y="292608"/>
+            <a:ext cx="8229600" cy="530353"/>
+          </a:xfrm>
+          <a:prstGeom prst="rect">
+            <a:avLst/>
+          </a:prstGeom>
+        </p:spPr>
+        <p:txBody>
+          <a:bodyPr lIns="0" tIns="0" rIns="0" bIns="0" anchor="ctr"/>
+          <a:lstStyle/>
+          <a:p>
+            <a:pPr/>
+            <a:r>
+              <a:t>Welcome to Snowtooth Mountain</a:t>
+            </a:r>
+          </a:p>
+        </p:txBody>
+      </p:sp>
+      <p:sp>
+        <p:nvSpPr>
+          <p:cNvPr id="1001" name="peak" descr="Decorative mountain"/>
+          <p:cNvSpPr/>
+          <p:nvPr/>
+        </p:nvSpPr>
+        <p:spPr>
+          <a:xfrm>
+            <a:off x="0" y="2400300"/>
+            <a:ext cx="4023360" cy="2743200"/>
+          </a:xfrm>
+          <a:prstGeom prst="triangle">
+            <a:avLst>
+              <a:gd name="adj" fmla="val 45000"/>
+            </a:avLst>
+          </a:prstGeom>
+          <a:solidFill>
+            <a:srgbClr val="171717"/>
+          </a:solidFill>
+          <a:ln>
+            <a:noFill/>
+          </a:ln>
+        </p:spPr>
+        <p:txBody>
+          <a:bodyPr/>
+          <a:lstStyle/>
+          <a:p>
+            <a:endParaRPr lang="en-US"/>
+          </a:p>
+        </p:txBody>
+      </p:sp>
+      <p:sp>
+        <p:nvSpPr>
+          <p:cNvPr id="1002" name="snowcap" descr="Decorative snowcap"/>
+          <p:cNvSpPr/>
+          <p:nvPr/>
+        </p:nvSpPr>
+        <p:spPr>
+          <a:xfrm>
+            <a:off x="1575145" y="2400300"/>
+            <a:ext cx="523037" cy="356616"/>
+          </a:xfrm>
+          <a:prstGeom prst="triangle">
+            <a:avLst>
+              <a:gd name="adj" fmla="val 45000"/>
+            </a:avLst>
+          </a:prstGeom>
+          <a:solidFill>
+            <a:srgbClr val="3A3A3A"/>
+          </a:solidFill>
+          <a:ln>
+            <a:noFill/>
+          </a:ln>
+        </p:spPr>
+        <p:txBody>
+          <a:bodyPr/>
+          <a:lstStyle/>
+          <a:p>
+            <a:endParaRPr lang="en-US"/>
+          </a:p>
+        </p:txBody>
+      </p:sp>
+      <p:sp>
+        <p:nvSpPr>
+          <p:cNvPr id="1003" name="peak" descr="Decorative mountain"/>
+          <p:cNvSpPr/>
+          <p:nvPr/>
+        </p:nvSpPr>
+        <p:spPr>
+          <a:xfrm>
+            <a:off x="5852160" y="2766060"/>
+            <a:ext cx="3291840" cy="2377440"/>
+          </a:xfrm>
+          <a:prstGeom prst="triangle">
+            <a:avLst>
+              <a:gd name="adj" fmla="val 55000"/>
+            </a:avLst>
+          </a:prstGeom>
+          <a:solidFill>
+            <a:srgbClr val="171717"/>
+          </a:solidFill>
+          <a:ln>
+            <a:noFill/>
+          </a:ln>
+        </p:spPr>
+        <p:txBody>
+          <a:bodyPr/>
+          <a:lstStyle/>
+          <a:p>
+            <a:endParaRPr lang="en-US"/>
+          </a:p>
+        </p:txBody>
+      </p:sp>
+      <p:sp>
+        <p:nvSpPr>
+          <p:cNvPr id="1004" name="snowcap" descr="Decorative snowcap"/>
+          <p:cNvSpPr/>
+          <p:nvPr/>
+        </p:nvSpPr>
+        <p:spPr>
+          <a:xfrm>
+            <a:off x="7427305" y="2766060"/>
+            <a:ext cx="427939" cy="309067"/>
+          </a:xfrm>
+          <a:prstGeom prst="triangle">
+            <a:avLst>
+              <a:gd name="adj" fmla="val 55000"/>
+            </a:avLst>
+          </a:prstGeom>
+          <a:solidFill>
+            <a:srgbClr val="3A3A3A"/>
+          </a:solidFill>
+          <a:ln>
+            <a:noFill/>
+          </a:ln>
+        </p:spPr>
+        <p:txBody>
+          <a:bodyPr/>
+          <a:lstStyle/>
+          <a:p>
+            <a:endParaRPr lang="en-US"/>
+          </a:p>
+        </p:txBody>
+      </p:sp>
+      <p:sp>
+        <p:nvSpPr>
+          <p:cNvPr id="1005" name="peak" descr="Decorative mountain"/>
+          <p:cNvSpPr/>
+          <p:nvPr/>
+        </p:nvSpPr>
+        <p:spPr>
+          <a:xfrm>
+            <a:off x="1463040" y="1303020"/>
+            <a:ext cx="6583680" cy="3840480"/>
+          </a:xfrm>
+          <a:prstGeom prst="triangle">
+            <a:avLst>
+              <a:gd name="adj" fmla="val 50000"/>
+            </a:avLst>
+          </a:prstGeom>
+          <a:solidFill>
+            <a:srgbClr val="1E1E1E"/>
+          </a:solidFill>
+          <a:ln>
+            <a:noFill/>
+          </a:ln>
+        </p:spPr>
+        <p:txBody>
+          <a:bodyPr/>
+          <a:lstStyle/>
+          <a:p>
+            <a:endParaRPr lang="en-US"/>
+          </a:p>
+        </p:txBody>
+      </p:sp>
+      <p:sp>
+        <p:nvSpPr>
+          <p:cNvPr id="1006" name="snowcap" descr="Decorative snowcap"/>
+          <p:cNvSpPr/>
+          <p:nvPr/>
+        </p:nvSpPr>
+        <p:spPr>
+          <a:xfrm>
+            <a:off x="4326941" y="1303020"/>
+            <a:ext cx="855878" cy="499262"/>
+          </a:xfrm>
+          <a:prstGeom prst="triangle">
+            <a:avLst>
+              <a:gd name="adj" fmla="val 50000"/>
+            </a:avLst>
+          </a:prstGeom>
+          <a:solidFill>
+            <a:srgbClr val="3A3A3A"/>
+          </a:solidFill>
+          <a:ln>
+            <a:noFill/>
+          </a:ln>
+        </p:spPr>
+        <p:txBody>
+          <a:bodyPr/>
+          <a:lstStyle/>
+          <a:p>
+            <a:endParaRPr lang="en-US"/>
+          </a:p>
+        </p:txBody>
+      </p:sp>
+      <p:cxnSp>
+        <p:nvCxnSpPr>
+          <p:cNvPr id="1007" name="lift"/>
+          <p:cNvCxnSpPr/>
+          <p:nvPr/>
+        </p:nvCxnSpPr>
+        <p:spPr>
+          <a:xfrm>
+            <a:off x="4791456" y="2011680"/>
+            <a:ext cx="192024" cy="2057400"/>
+          </a:xfrm>
+          <a:prstGeom prst="line">
+            <a:avLst/>
+          </a:prstGeom>
+          <a:ln w="12700" cap="rnd">
+            <a:solidFill>
+              <a:srgbClr val="8A8A8A"/>
+            </a:solidFill>
+            <a:prstDash val="sysDot"/>
+            <a:round/>
+          </a:ln>
+        </p:spPr>
+      </p:cxnSp>
+      <p:sp>
+        <p:nvSpPr>
+          <p:cNvPr id="1008" name="lift-top"/>
+          <p:cNvSpPr/>
+          <p:nvPr/>
+        </p:nvSpPr>
+        <p:spPr>
+          <a:xfrm>
+            <a:off x="4759452" y="1979676"/>
+            <a:ext cx="64008" cy="64008"/>
+          </a:xfrm>
+          <a:prstGeom prst="ellipse">
+            <a:avLst/>
+          </a:prstGeom>
+          <a:solidFill>
+            <a:srgbClr val="8A8A8A"/>
+          </a:solidFill>
+          <a:ln>
+            <a:noFill/>
+          </a:ln>
+        </p:spPr>
+        <p:txBody>
+          <a:bodyPr/>
+          <a:lstStyle/>
+          <a:p>
+            <a:endParaRPr lang="en-US"/>
+          </a:p>
+        </p:txBody>
+      </p:sp>
+      <p:cxnSp>
+        <p:nvCxnSpPr>
+          <p:cNvPr id="1009" name="lift"/>
+          <p:cNvCxnSpPr/>
+          <p:nvPr/>
+        </p:nvCxnSpPr>
+        <p:spPr>
+          <a:xfrm>
+            <a:off x="1847088" y="2788920"/>
+            <a:ext cx="393192" cy="1554480"/>
+          </a:xfrm>
+          <a:prstGeom prst="line">
+            <a:avLst/>
+          </a:prstGeom>
+          <a:ln w="12700" cap="rnd">
+            <a:solidFill>
+              <a:srgbClr val="8A8A8A"/>
+            </a:solidFill>
+            <a:prstDash val="sysDot"/>
+            <a:round/>
+          </a:ln>
+        </p:spPr>
+      </p:cxnSp>
+      <p:sp>
+        <p:nvSpPr>
+          <p:cNvPr id="1010" name="lift-top"/>
+          <p:cNvSpPr/>
+          <p:nvPr/>
+        </p:nvSpPr>
+        <p:spPr>
+          <a:xfrm>
+            <a:off x="1815084" y="2756916"/>
+            <a:ext cx="64008" cy="64008"/>
+          </a:xfrm>
+          <a:prstGeom prst="ellipse">
+            <a:avLst/>
+          </a:prstGeom>
+          <a:solidFill>
+            <a:srgbClr val="8A8A8A"/>
+          </a:solidFill>
+          <a:ln>
+            <a:noFill/>
+          </a:ln>
+        </p:spPr>
+        <p:txBody>
+          <a:bodyPr/>
+          <a:lstStyle/>
+          <a:p>
+            <a:endParaRPr lang="en-US"/>
+          </a:p>
+        </p:txBody>
+      </p:sp>
+      <p:cxnSp>
+        <p:nvCxnSpPr>
+          <p:cNvPr id="1011" name="run-Sneaky Pete"/>
+          <p:cNvCxnSpPr/>
+          <p:nvPr/>
+        </p:nvCxnSpPr>
+        <p:spPr>
+          <a:xfrm flipH="1">
+            <a:off x="1280160" y="2697480"/>
+            <a:ext cx="502920" cy="868680"/>
+          </a:xfrm>
+          <a:prstGeom prst="line">
+            <a:avLst/>
+          </a:prstGeom>
+          <a:ln w="28575" cap="rnd">
+            <a:solidFill>
+              <a:srgbClr val="1F9D55"/>
+            </a:solidFill>
+            <a:round/>
+          </a:ln>
+        </p:spPr>
+      </p:cxnSp>
+      <p:cxnSp>
+        <p:nvCxnSpPr>
+          <p:cNvPr id="1012" name="run-Sneaky Pete"/>
+          <p:cNvCxnSpPr/>
+          <p:nvPr/>
+        </p:nvCxnSpPr>
+        <p:spPr>
+          <a:xfrm flipH="1">
+            <a:off x="1188720" y="3566160"/>
+            <a:ext cx="91440" cy="822960"/>
+          </a:xfrm>
+          <a:prstGeom prst="line">
+            <a:avLst/>
+          </a:prstGeom>
+          <a:ln w="28575" cap="rnd">
+            <a:solidFill>
+              <a:srgbClr val="1F9D55"/>
+            </a:solidFill>
+            <a:round/>
+          </a:ln>
+        </p:spPr>
+      </p:cxnSp>
+      <p:sp>
+        <p:nvSpPr>
+          <p:cNvPr id="1013" name="marker-green" descr="Beginner"/>
+          <p:cNvSpPr/>
+          <p:nvPr/>
+        </p:nvSpPr>
+        <p:spPr>
+          <a:xfrm>
+            <a:off x="1723644" y="2638044"/>
+            <a:ext cx="118872" cy="118872"/>
+          </a:xfrm>
+          <a:prstGeom prst="ellipse">
+            <a:avLst/>
+          </a:prstGeom>
+          <a:solidFill>
+            <a:srgbClr val="1F9D55"/>
+          </a:solidFill>
+          <a:ln>
+            <a:noFill/>
+          </a:ln>
+        </p:spPr>
+        <p:txBody>
+          <a:bodyPr/>
+          <a:lstStyle/>
+          <a:p>
+            <a:endParaRPr lang="en-US"/>
+          </a:p>
+        </p:txBody>
+      </p:sp>
+      <p:sp>
+        <p:nvSpPr>
+          <p:cNvPr id="1014" name="run-label-Sneaky Pete"/>
+          <p:cNvSpPr txBox="1"/>
+          <p:nvPr/>
+        </p:nvSpPr>
+        <p:spPr>
+          <a:xfrm>
+            <a:off x="502920" y="4498848"/>
+            <a:ext cx="1371600" cy="201168"/>
+          </a:xfrm>
+          <a:prstGeom prst="rect">
+            <a:avLst/>
+          </a:prstGeom>
+          <a:noFill/>
+        </p:spPr>
+        <p:txBody>
+          <a:bodyPr wrap="none" lIns="0" tIns="0" rIns="0" bIns="0" anchor="ctr"/>
+          <a:lstStyle/>
+          <a:p>
+            <a:pPr algn="ctr"/>
+            <a:r>
+              <a:rPr lang="en-US" sz="900">
+                <a:solidFill>
+                  <a:srgbClr val="F2F2F2"/>
+                </a:solidFill>
+                <a:latin typeface="Arial"/>
+                <a:cs typeface="Arial"/>
+              </a:rPr>
+              <a:t>Sneaky Pete</a:t>
+            </a:r>
+          </a:p>
+        </p:txBody>
+      </p:sp>
+      <p:cxnSp>
+        <p:nvCxnSpPr>
+          <p:cNvPr id="1015" name="run-Meow Face"/>
+          <p:cNvCxnSpPr/>
+          <p:nvPr/>
+        </p:nvCxnSpPr>
+        <p:spPr>
+          <a:xfrm flipH="1">
+            <a:off x="3566160" y="2103120"/>
+            <a:ext cx="713232" cy="822960"/>
+          </a:xfrm>
+          <a:prstGeom prst="line">
+            <a:avLst/>
+          </a:prstGeom>
+          <a:ln w="28575" cap="rnd">
+            <a:solidFill>
+              <a:srgbClr val="3B82F6"/>
+            </a:solidFill>
+            <a:round/>
+          </a:ln>
+        </p:spPr>
+      </p:cxnSp>
+      <p:cxnSp>
+        <p:nvCxnSpPr>
+          <p:cNvPr id="1016" name="run-Meow Face"/>
+          <p:cNvCxnSpPr/>
+          <p:nvPr/>
+        </p:nvCxnSpPr>
+        <p:spPr>
+          <a:xfrm flipH="1">
+            <a:off x="2651760" y="2926080"/>
+            <a:ext cx="914400" cy="1463040"/>
+          </a:xfrm>
+          <a:prstGeom prst="line">
+            <a:avLst/>
+          </a:prstGeom>
+          <a:ln w="28575" cap="rnd">
+            <a:solidFill>
+              <a:srgbClr val="3B82F6"/>
+            </a:solidFill>
+            <a:round/>
+          </a:ln>
+        </p:spPr>
+      </p:cxnSp>
+      <p:sp>
+        <p:nvSpPr>
+          <p:cNvPr id="1017" name="marker-blue" descr="Intermediate"/>
+          <p:cNvSpPr/>
+          <p:nvPr/>
+        </p:nvSpPr>
+        <p:spPr>
+          <a:xfrm>
+            <a:off x="4225900" y="2049628"/>
+            <a:ext cx="106985" cy="106985"/>
+          </a:xfrm>
+          <a:prstGeom prst="rect">
+            <a:avLst/>
+          </a:prstGeom>
+          <a:solidFill>
+            <a:srgbClr val="3B82F6"/>
+          </a:solidFill>
+          <a:ln>
+            <a:noFill/>
+          </a:ln>
+        </p:spPr>
+        <p:txBody>
+          <a:bodyPr/>
+          <a:lstStyle/>
+          <a:p>
+            <a:endParaRPr lang="en-US"/>
+          </a:p>
+        </p:txBody>
+      </p:sp>
+      <p:sp>
+        <p:nvSpPr>
+          <p:cNvPr id="1018" name="run-label-Meow Face"/>
+          <p:cNvSpPr txBox="1"/>
+          <p:nvPr/>
+        </p:nvSpPr>
+        <p:spPr>
+          <a:xfrm>
+            <a:off x="1965960" y="4498848"/>
+            <a:ext cx="1371600" cy="201168"/>
+          </a:xfrm>
+          <a:prstGeom prst="rect">
+            <a:avLst/>
+          </a:prstGeom>
+          <a:noFill/>
+        </p:spPr>
+        <p:txBody>
+          <a:bodyPr wrap="none" lIns="0" tIns="0" rIns="0" bIns="0" anchor="ctr"/>
+          <a:lstStyle/>
+          <a:p>
+            <a:pPr algn="ctr"/>
+            <a:r>
+              <a:rPr lang="en-US" sz="900">
+                <a:solidFill>
+                  <a:srgbClr val="F2F2F2"/>
+                </a:solidFill>
+                <a:latin typeface="Arial"/>
+                <a:cs typeface="Arial"/>
+              </a:rPr>
+              <a:t>Meow Face</a:t>
+            </a:r>
+          </a:p>
+        </p:txBody>
+      </p:sp>
+      <p:cxnSp>
+        <p:nvCxnSpPr>
+          <p:cNvPr id="1019" name="run-Golden Ticket"/>
+          <p:cNvCxnSpPr/>
+          <p:nvPr/>
+        </p:nvCxnSpPr>
+        <p:spPr>
+          <a:xfrm flipH="1">
+            <a:off x="4160520" y="1691640"/>
+            <a:ext cx="393192" cy="1143000"/>
+          </a:xfrm>
+          <a:prstGeom prst="line">
+            <a:avLst/>
+          </a:prstGeom>
+          <a:ln w="28575" cap="rnd">
+            <a:solidFill>
+              <a:srgbClr val="F2F2F2"/>
+            </a:solidFill>
+            <a:prstDash val="dash"/>
+            <a:round/>
+          </a:ln>
+        </p:spPr>
+      </p:cxnSp>
+      <p:cxnSp>
+        <p:nvCxnSpPr>
+          <p:cNvPr id="1020" name="run-Golden Ticket"/>
+          <p:cNvCxnSpPr/>
+          <p:nvPr/>
+        </p:nvCxnSpPr>
+        <p:spPr>
+          <a:xfrm flipH="1">
+            <a:off x="3931920" y="2834640"/>
+            <a:ext cx="228600" cy="1554480"/>
+          </a:xfrm>
+          <a:prstGeom prst="line">
+            <a:avLst/>
+          </a:prstGeom>
+          <a:ln w="28575" cap="rnd">
+            <a:solidFill>
+              <a:srgbClr val="F2F2F2"/>
+            </a:solidFill>
+            <a:prstDash val="dash"/>
+            <a:round/>
+          </a:ln>
+        </p:spPr>
+      </p:cxnSp>
+      <p:sp>
+        <p:nvSpPr>
+          <p:cNvPr id="1021" name="marker-black" descr="Expert"/>
+          <p:cNvSpPr/>
+          <p:nvPr/>
+        </p:nvSpPr>
+        <p:spPr>
+          <a:xfrm>
+            <a:off x="4407865" y="1623289"/>
+            <a:ext cx="136703" cy="136703"/>
+          </a:xfrm>
+          <a:prstGeom prst="diamond">
+            <a:avLst/>
+          </a:prstGeom>
+          <a:solidFill>
+            <a:srgbClr val="0A0A0A"/>
+          </a:solidFill>
+          <a:ln w="12700">
+            <a:solidFill>
+              <a:srgbClr val="F2F2F2"/>
+            </a:solidFill>
+          </a:ln>
+        </p:spPr>
+        <p:txBody>
+          <a:bodyPr/>
+          <a:lstStyle/>
+          <a:p>
+            <a:endParaRPr lang="en-US"/>
+          </a:p>
+        </p:txBody>
+      </p:sp>
+      <p:sp>
+        <p:nvSpPr>
+          <p:cNvPr id="1022" name="marker-black" descr="Expert"/>
+          <p:cNvSpPr/>
+          <p:nvPr/>
+        </p:nvSpPr>
+        <p:spPr>
+          <a:xfrm>
+            <a:off x="4562856" y="1623289"/>
+            <a:ext cx="136703" cy="136703"/>
+          </a:xfrm>
+          <a:prstGeom prst="diamond">
+            <a:avLst/>
+          </a:prstGeom>
+          <a:solidFill>
+            <a:srgbClr val="0A0A0A"/>
+          </a:solidFill>
+          <a:ln w="12700">
+            <a:solidFill>
+              <a:srgbClr val="F2F2F2"/>
+            </a:solidFill>
+          </a:ln>
+        </p:spPr>
+        <p:txBody>
+          <a:bodyPr/>
+          <a:lstStyle/>
+          <a:p>
+            <a:endParaRPr lang="en-US"/>
+          </a:p>
+        </p:txBody>
+      </p:sp>
+      <p:sp>
+        <p:nvSpPr>
+          <p:cNvPr id="1023" name="run-label-Golden Ticket"/>
+          <p:cNvSpPr txBox="1"/>
+          <p:nvPr/>
+        </p:nvSpPr>
+        <p:spPr>
+          <a:xfrm>
+            <a:off x="3246120" y="4498848"/>
+            <a:ext cx="1371600" cy="201168"/>
+          </a:xfrm>
+          <a:prstGeom prst="rect">
+            <a:avLst/>
+          </a:prstGeom>
+          <a:noFill/>
+        </p:spPr>
+        <p:txBody>
+          <a:bodyPr wrap="none" lIns="0" tIns="0" rIns="0" bIns="0" anchor="ctr"/>
+          <a:lstStyle/>
+          <a:p>
+            <a:pPr algn="ctr"/>
+            <a:r>
+              <a:rPr lang="en-US" sz="900">
+                <a:solidFill>
+                  <a:srgbClr val="F2F2F2"/>
+                </a:solidFill>
+                <a:latin typeface="Arial"/>
+                <a:cs typeface="Arial"/>
+              </a:rPr>
+              <a:t>Golden Ticket</a:t>
+            </a:r>
+          </a:p>
+        </p:txBody>
+      </p:sp>
+      <p:cxnSp>
+        <p:nvCxnSpPr>
+          <p:cNvPr id="1024" name="run-Parker Downhill"/>
+          <p:cNvCxnSpPr/>
+          <p:nvPr/>
+        </p:nvCxnSpPr>
+        <p:spPr>
+          <a:xfrm>
+            <a:off x="5029200" y="1920240"/>
+            <a:ext cx="457200" cy="822960"/>
+          </a:xfrm>
+          <a:prstGeom prst="line">
+            <a:avLst/>
+          </a:prstGeom>
+          <a:ln w="28575" cap="rnd">
+            <a:solidFill>
+              <a:srgbClr val="F2F2F2"/>
+            </a:solidFill>
+            <a:round/>
+          </a:ln>
+        </p:spPr>
+      </p:cxnSp>
+      <p:cxnSp>
+        <p:nvCxnSpPr>
+          <p:cNvPr id="1025" name="run-Parker Downhill"/>
+          <p:cNvCxnSpPr/>
+          <p:nvPr/>
+        </p:nvCxnSpPr>
+        <p:spPr>
+          <a:xfrm>
+            <a:off x="5486400" y="2743200"/>
+            <a:ext cx="137160" cy="1645920"/>
+          </a:xfrm>
+          <a:prstGeom prst="line">
+            <a:avLst/>
+          </a:prstGeom>
+          <a:ln w="28575" cap="rnd">
+            <a:solidFill>
+              <a:srgbClr val="F2F2F2"/>
+            </a:solidFill>
+            <a:round/>
+          </a:ln>
+        </p:spPr>
+      </p:cxnSp>
+      <p:sp>
+        <p:nvSpPr>
+          <p:cNvPr id="1026" name="marker-black" descr="Advanced"/>
+          <p:cNvSpPr/>
+          <p:nvPr/>
+        </p:nvSpPr>
+        <p:spPr>
+          <a:xfrm>
+            <a:off x="4960849" y="1851889"/>
+            <a:ext cx="136703" cy="136703"/>
+          </a:xfrm>
+          <a:prstGeom prst="diamond">
+            <a:avLst/>
+          </a:prstGeom>
+          <a:solidFill>
+            <a:srgbClr val="0A0A0A"/>
+          </a:solidFill>
+          <a:ln w="12700">
+            <a:solidFill>
+              <a:srgbClr val="F2F2F2"/>
+            </a:solidFill>
+          </a:ln>
+        </p:spPr>
+        <p:txBody>
+          <a:bodyPr/>
+          <a:lstStyle/>
+          <a:p>
+            <a:endParaRPr lang="en-US"/>
+          </a:p>
+        </p:txBody>
+      </p:sp>
+      <p:sp>
+        <p:nvSpPr>
+          <p:cNvPr id="1027" name="run-label-Parker Downhill"/>
+          <p:cNvSpPr txBox="1"/>
+          <p:nvPr/>
+        </p:nvSpPr>
+        <p:spPr>
+          <a:xfrm>
+            <a:off x="4937760" y="4498848"/>
+            <a:ext cx="1371600" cy="201168"/>
+          </a:xfrm>
+          <a:prstGeom prst="rect">
+            <a:avLst/>
+          </a:prstGeom>
+          <a:noFill/>
+        </p:spPr>
+        <p:txBody>
+          <a:bodyPr wrap="none" lIns="0" tIns="0" rIns="0" bIns="0" anchor="ctr"/>
+          <a:lstStyle/>
+          <a:p>
+            <a:pPr algn="ctr"/>
+            <a:r>
+              <a:rPr lang="en-US" sz="900">
+                <a:solidFill>
+                  <a:srgbClr val="F2F2F2"/>
+                </a:solidFill>
+                <a:latin typeface="Arial"/>
+                <a:cs typeface="Arial"/>
+              </a:rPr>
+              <a:t>Parker Downhill</a:t>
+            </a:r>
+          </a:p>
+        </p:txBody>
+      </p:sp>
+      <p:cxnSp>
+        <p:nvCxnSpPr>
+          <p:cNvPr id="1028" name="run-Michigan Ave"/>
+          <p:cNvCxnSpPr/>
+          <p:nvPr/>
+        </p:nvCxnSpPr>
+        <p:spPr>
+          <a:xfrm>
+            <a:off x="5303520" y="2286000"/>
+            <a:ext cx="731520" cy="685800"/>
+          </a:xfrm>
+          <a:prstGeom prst="line">
+            <a:avLst/>
+          </a:prstGeom>
+          <a:ln w="28575" cap="rnd">
+            <a:solidFill>
+              <a:srgbClr val="3B82F6"/>
+            </a:solidFill>
+            <a:round/>
+          </a:ln>
+        </p:spPr>
+      </p:cxnSp>
+      <p:cxnSp>
+        <p:nvCxnSpPr>
+          <p:cNvPr id="1029" name="run-Michigan Ave"/>
+          <p:cNvCxnSpPr/>
+          <p:nvPr/>
+        </p:nvCxnSpPr>
+        <p:spPr>
+          <a:xfrm>
+            <a:off x="6035040" y="2971800"/>
+            <a:ext cx="868680" cy="1417320"/>
+          </a:xfrm>
+          <a:prstGeom prst="line">
+            <a:avLst/>
+          </a:prstGeom>
+          <a:ln w="28575" cap="rnd">
+            <a:solidFill>
+              <a:srgbClr val="3B82F6"/>
+            </a:solidFill>
+            <a:round/>
+          </a:ln>
+        </p:spPr>
+      </p:cxnSp>
+      <p:sp>
+        <p:nvSpPr>
+          <p:cNvPr id="1030" name="marker-blue" descr="Intermediate"/>
+          <p:cNvSpPr/>
+          <p:nvPr/>
+        </p:nvSpPr>
+        <p:spPr>
+          <a:xfrm>
+            <a:off x="5250028" y="2232508"/>
+            <a:ext cx="106985" cy="106985"/>
+          </a:xfrm>
+          <a:prstGeom prst="rect">
+            <a:avLst/>
+          </a:prstGeom>
+          <a:solidFill>
+            <a:srgbClr val="3B82F6"/>
+          </a:solidFill>
+          <a:ln>
+            <a:noFill/>
+          </a:ln>
+        </p:spPr>
+        <p:txBody>
+          <a:bodyPr/>
+          <a:lstStyle/>
+          <a:p>
+            <a:endParaRPr lang="en-US"/>
+          </a:p>
+        </p:txBody>
+      </p:sp>
+      <p:sp>
+        <p:nvSpPr>
+          <p:cNvPr id="1031" name="run-label-Michigan Ave"/>
+          <p:cNvSpPr txBox="1"/>
+          <p:nvPr/>
+        </p:nvSpPr>
+        <p:spPr>
+          <a:xfrm>
+            <a:off x="6217920" y="4498848"/>
+            <a:ext cx="1371600" cy="201168"/>
+          </a:xfrm>
+          <a:prstGeom prst="rect">
+            <a:avLst/>
+          </a:prstGeom>
+          <a:noFill/>
+        </p:spPr>
+        <p:txBody>
+          <a:bodyPr wrap="none" lIns="0" tIns="0" rIns="0" bIns="0" anchor="ctr"/>
+          <a:lstStyle/>
+          <a:p>
+            <a:pPr algn="ctr"/>
+            <a:r>
+              <a:rPr lang="en-US" sz="900">
+                <a:solidFill>
+                  <a:srgbClr val="F2F2F2"/>
+                </a:solidFill>
+                <a:latin typeface="Arial"/>
+                <a:cs typeface="Arial"/>
+              </a:rPr>
+              <a:t>Michigan Ave</a:t>
+            </a:r>
+          </a:p>
+        </p:txBody>
+      </p:sp>
+      <p:cxnSp>
+        <p:nvCxnSpPr>
+          <p:cNvPr id="1032" name="run-Wiggle Waggle"/>
+          <p:cNvCxnSpPr/>
+          <p:nvPr/>
+        </p:nvCxnSpPr>
+        <p:spPr>
+          <a:xfrm>
+            <a:off x="7680960" y="3017520"/>
+            <a:ext cx="320040" cy="640080"/>
+          </a:xfrm>
+          <a:prstGeom prst="line">
+            <a:avLst/>
+          </a:prstGeom>
+          <a:ln w="28575" cap="rnd">
+            <a:solidFill>
+              <a:srgbClr val="1F9D55"/>
+            </a:solidFill>
+            <a:round/>
+          </a:ln>
+        </p:spPr>
+      </p:cxnSp>
+      <p:cxnSp>
+        <p:nvCxnSpPr>
+          <p:cNvPr id="1033" name="run-Wiggle Waggle"/>
+          <p:cNvCxnSpPr/>
+          <p:nvPr/>
+        </p:nvCxnSpPr>
+        <p:spPr>
+          <a:xfrm>
+            <a:off x="8001000" y="3657600"/>
+            <a:ext cx="91440" cy="731520"/>
+          </a:xfrm>
+          <a:prstGeom prst="line">
+            <a:avLst/>
+          </a:prstGeom>
+          <a:ln w="28575" cap="rnd">
+            <a:solidFill>
+              <a:srgbClr val="1F9D55"/>
+            </a:solidFill>
+            <a:round/>
+          </a:ln>
+        </p:spPr>
+      </p:cxnSp>
+      <p:sp>
+        <p:nvSpPr>
+          <p:cNvPr id="1034" name="marker-green" descr="Beginner"/>
+          <p:cNvSpPr/>
+          <p:nvPr/>
+        </p:nvSpPr>
+        <p:spPr>
+          <a:xfrm>
+            <a:off x="7621524" y="2958084"/>
+            <a:ext cx="118872" cy="118872"/>
+          </a:xfrm>
+          <a:prstGeom prst="ellipse">
+            <a:avLst/>
+          </a:prstGeom>
+          <a:solidFill>
+            <a:srgbClr val="1F9D55"/>
+          </a:solidFill>
+          <a:ln>
+            <a:noFill/>
+          </a:ln>
+        </p:spPr>
+        <p:txBody>
+          <a:bodyPr/>
+          <a:lstStyle/>
+          <a:p>
+            <a:endParaRPr lang="en-US"/>
+          </a:p>
+        </p:txBody>
+      </p:sp>
+      <p:sp>
+        <p:nvSpPr>
+          <p:cNvPr id="1035" name="run-label-Wiggle Waggle"/>
+          <p:cNvSpPr txBox="1"/>
+          <p:nvPr/>
+        </p:nvSpPr>
+        <p:spPr>
+          <a:xfrm>
+            <a:off x="7406640" y="4498848"/>
+            <a:ext cx="1371600" cy="201168"/>
+          </a:xfrm>
+          <a:prstGeom prst="rect">
+            <a:avLst/>
+          </a:prstGeom>
+          <a:noFill/>
+        </p:spPr>
+        <p:txBody>
+          <a:bodyPr wrap="none" lIns="0" tIns="0" rIns="0" bIns="0" anchor="ctr"/>
+          <a:lstStyle/>
+          <a:p>
+            <a:pPr algn="ctr"/>
+            <a:r>
+              <a:rPr lang="en-US" sz="900">
+                <a:solidFill>
+                  <a:srgbClr val="F2F2F2"/>
+                </a:solidFill>
+                <a:latin typeface="Arial"/>
+                <a:cs typeface="Arial"/>
+              </a:rPr>
+              <a:t>Wiggle Waggle</a:t>
+            </a:r>
+          </a:p>
+        </p:txBody>
+      </p:sp>
+      <p:sp>
+        <p:nvSpPr>
+          <p:cNvPr id="1036" name="lodge" descr="Lodge"/>
+          <p:cNvSpPr/>
+          <p:nvPr/>
+        </p:nvSpPr>
+        <p:spPr>
+          <a:xfrm>
+            <a:off x="4526280" y="4069080"/>
+            <a:ext cx="914400" cy="246888"/>
+          </a:xfrm>
+          <a:prstGeom prst="rect">
+            <a:avLst/>
+          </a:prstGeom>
+          <a:solidFill>
+            <a:srgbClr val="2E2E2E"/>
+          </a:solidFill>
+          <a:ln>
+            <a:noFill/>
+          </a:ln>
+        </p:spPr>
+        <p:txBody>
+          <a:bodyPr/>
+          <a:lstStyle/>
+          <a:p>
+            <a:endParaRPr lang="en-US"/>
+          </a:p>
+        </p:txBody>
+      </p:sp>
+      <p:sp>
+        <p:nvSpPr>
+          <p:cNvPr id="1037" name="lodge-label"/>
+          <p:cNvSpPr txBox="1"/>
+          <p:nvPr/>
+        </p:nvSpPr>
+        <p:spPr>
+          <a:xfrm>
+            <a:off x="4526280" y="4069080"/>
+            <a:ext cx="914400" cy="246888"/>
+          </a:xfrm>
+          <a:prstGeom prst="rect">
+            <a:avLst/>
+          </a:prstGeom>
+          <a:noFill/>
+        </p:spPr>
+        <p:txBody>
+          <a:bodyPr wrap="none" lIns="0" tIns="0" rIns="0" bIns="0" anchor="ctr"/>
+          <a:lstStyle/>
+          <a:p>
+            <a:pPr algn="ctr"/>
+            <a:r>
+              <a:rPr lang="en-US" sz="800">
+                <a:solidFill>
+                  <a:srgbClr val="F2F2F2"/>
+                </a:solidFill>
+                <a:latin typeface="Courier New"/>
+                <a:cs typeface="Courier New"/>
+              </a:rPr>
+              <a:t>LODGE</a:t>
+            </a:r>
+          </a:p>
+        </p:txBody>
+      </p:sp>
+      <p:sp>
+        <p:nvSpPr>
+          <p:cNvPr id="1038" name="marker-green" descr="Beginner"/>
+          <p:cNvSpPr/>
+          <p:nvPr/>
+        </p:nvSpPr>
+        <p:spPr>
+          <a:xfrm>
+            <a:off x="5449824" y="960120"/>
+            <a:ext cx="109728" cy="109728"/>
+          </a:xfrm>
+          <a:prstGeom prst="ellipse">
+            <a:avLst/>
+          </a:prstGeom>
+          <a:solidFill>
+            <a:srgbClr val="1F9D55"/>
+          </a:solidFill>
+          <a:ln>
+            <a:noFill/>
+          </a:ln>
+        </p:spPr>
+        <p:txBody>
+          <a:bodyPr/>
+          <a:lstStyle/>
+          <a:p>
+            <a:endParaRPr lang="en-US"/>
+          </a:p>
+        </p:txBody>
+      </p:sp>
+      <p:sp>
+        <p:nvSpPr>
+          <p:cNvPr id="1039" name="legend-beginner"/>
+          <p:cNvSpPr txBox="1"/>
+          <p:nvPr/>
+        </p:nvSpPr>
+        <p:spPr>
+          <a:xfrm>
+            <a:off x="5623560" y="914400"/>
+            <a:ext cx="868680" cy="201168"/>
+          </a:xfrm>
+          <a:prstGeom prst="rect">
+            <a:avLst/>
+          </a:prstGeom>
+          <a:noFill/>
+        </p:spPr>
+        <p:txBody>
+          <a:bodyPr wrap="none" lIns="0" tIns="0" rIns="0" bIns="0" anchor="ctr"/>
+          <a:lstStyle/>
+          <a:p>
+            <a:pPr algn="l"/>
+            <a:r>
+              <a:rPr lang="en-US" sz="900">
+                <a:solidFill>
+                  <a:srgbClr val="8A8A8A"/>
+                </a:solidFill>
+                <a:latin typeface="Arial"/>
+                <a:cs typeface="Arial"/>
+              </a:rPr>
+              <a:t>Beginner</a:t>
+            </a:r>
+          </a:p>
+        </p:txBody>
+      </p:sp>
+      <p:sp>
+        <p:nvSpPr>
+          <p:cNvPr id="1040" name="marker-blue" descr="Intermediate"/>
+          <p:cNvSpPr/>
+          <p:nvPr/>
+        </p:nvSpPr>
+        <p:spPr>
+          <a:xfrm>
+            <a:off x="6323990" y="965606"/>
+            <a:ext cx="98755" cy="98755"/>
+          </a:xfrm>
+          <a:prstGeom prst="rect">
+            <a:avLst/>
+          </a:prstGeom>
+          <a:solidFill>
+            <a:srgbClr val="3B82F6"/>
+          </a:solidFill>
+          <a:ln>
+            <a:noFill/>
+          </a:ln>
+        </p:spPr>
+        <p:txBody>
+          <a:bodyPr/>
+          <a:lstStyle/>
+          <a:p>
+            <a:endParaRPr lang="en-US"/>
+          </a:p>
+        </p:txBody>
+      </p:sp>
+      <p:sp>
+        <p:nvSpPr>
+          <p:cNvPr id="1041" name="legend-intermediate"/>
+          <p:cNvSpPr txBox="1"/>
+          <p:nvPr/>
+        </p:nvSpPr>
+        <p:spPr>
+          <a:xfrm>
+            <a:off x="6492240" y="914400"/>
+            <a:ext cx="1097280" cy="201168"/>
+          </a:xfrm>
+          <a:prstGeom prst="rect">
+            <a:avLst/>
+          </a:prstGeom>
+          <a:noFill/>
+        </p:spPr>
+        <p:txBody>
+          <a:bodyPr wrap="none" lIns="0" tIns="0" rIns="0" bIns="0" anchor="ctr"/>
+          <a:lstStyle/>
+          <a:p>
+            <a:pPr algn="l"/>
+            <a:r>
+              <a:rPr lang="en-US" sz="900">
+                <a:solidFill>
+                  <a:srgbClr val="8A8A8A"/>
+                </a:solidFill>
+                <a:latin typeface="Arial"/>
+                <a:cs typeface="Arial"/>
+              </a:rPr>
+              <a:t>Intermediate</a:t>
+            </a:r>
+          </a:p>
+        </p:txBody>
+      </p:sp>
+      <p:sp>
+        <p:nvSpPr>
+          <p:cNvPr id="1042" name="marker-black" descr="Advanced"/>
+          <p:cNvSpPr/>
+          <p:nvPr/>
+        </p:nvSpPr>
+        <p:spPr>
+          <a:xfrm>
+            <a:off x="7407554" y="951890"/>
+            <a:ext cx="126187" cy="126187"/>
+          </a:xfrm>
+          <a:prstGeom prst="diamond">
+            <a:avLst/>
+          </a:prstGeom>
+          <a:solidFill>
+            <a:srgbClr val="0A0A0A"/>
+          </a:solidFill>
+          <a:ln w="12700">
+            <a:solidFill>
+              <a:srgbClr val="F2F2F2"/>
+            </a:solidFill>
+          </a:ln>
+        </p:spPr>
+        <p:txBody>
+          <a:bodyPr/>
+          <a:lstStyle/>
+          <a:p>
+            <a:endParaRPr lang="en-US"/>
+          </a:p>
+        </p:txBody>
+      </p:sp>
+      <p:sp>
+        <p:nvSpPr>
+          <p:cNvPr id="1043" name="legend-advanced"/>
+          <p:cNvSpPr txBox="1"/>
+          <p:nvPr/>
+        </p:nvSpPr>
+        <p:spPr>
+          <a:xfrm>
+            <a:off x="7589520" y="914400"/>
+            <a:ext cx="960120" cy="201168"/>
+          </a:xfrm>
+          <a:prstGeom prst="rect">
+            <a:avLst/>
+          </a:prstGeom>
+          <a:noFill/>
+        </p:spPr>
+        <p:txBody>
+          <a:bodyPr wrap="none" lIns="0" tIns="0" rIns="0" bIns="0" anchor="ctr"/>
+          <a:lstStyle/>
+          <a:p>
+            <a:pPr algn="l"/>
+            <a:r>
+              <a:rPr lang="en-US" sz="900">
+                <a:solidFill>
+                  <a:srgbClr val="8A8A8A"/>
+                </a:solidFill>
+                <a:latin typeface="Arial"/>
+                <a:cs typeface="Arial"/>
+              </a:rPr>
+              <a:t>Advanced</a:t>
+            </a:r>
+          </a:p>
+        </p:txBody>
+      </p:sp>
+      <p:sp>
+        <p:nvSpPr>
+          <p:cNvPr id="1044" name="marker-black" descr="Expert"/>
+          <p:cNvSpPr/>
+          <p:nvPr/>
+        </p:nvSpPr>
+        <p:spPr>
+          <a:xfrm>
+            <a:off x="8359445" y="951890"/>
+            <a:ext cx="126187" cy="126187"/>
+          </a:xfrm>
+          <a:prstGeom prst="diamond">
+            <a:avLst/>
+          </a:prstGeom>
+          <a:solidFill>
+            <a:srgbClr val="0A0A0A"/>
+          </a:solidFill>
+          <a:ln w="12700">
+            <a:solidFill>
+              <a:srgbClr val="F2F2F2"/>
+            </a:solidFill>
+          </a:ln>
+        </p:spPr>
+        <p:txBody>
+          <a:bodyPr/>
+          <a:lstStyle/>
+          <a:p>
+            <a:endParaRPr lang="en-US"/>
+          </a:p>
+        </p:txBody>
+      </p:sp>
+      <p:sp>
+        <p:nvSpPr>
+          <p:cNvPr id="1045" name="marker-black" descr="Expert"/>
+          <p:cNvSpPr/>
+          <p:nvPr/>
+        </p:nvSpPr>
+        <p:spPr>
+          <a:xfrm>
+            <a:off x="8503920" y="951890"/>
+            <a:ext cx="126187" cy="126187"/>
+          </a:xfrm>
+          <a:prstGeom prst="diamond">
+            <a:avLst/>
+          </a:prstGeom>
+          <a:solidFill>
+            <a:srgbClr val="0A0A0A"/>
+          </a:solidFill>
+          <a:ln w="12700">
+            <a:solidFill>
+              <a:srgbClr val="F2F2F2"/>
+            </a:solidFill>
+          </a:ln>
+        </p:spPr>
+        <p:txBody>
+          <a:bodyPr/>
+          <a:lstStyle/>
+          <a:p>
+            <a:endParaRPr lang="en-US"/>
+          </a:p>
+        </p:txBody>
+      </p:sp>
+      <p:sp>
+        <p:nvSpPr>
+          <p:cNvPr id="1046" name="legend-expert"/>
+          <p:cNvSpPr txBox="1"/>
+          <p:nvPr/>
+        </p:nvSpPr>
+        <p:spPr>
+          <a:xfrm>
+            <a:off x="8677656" y="914400"/>
+            <a:ext cx="822960" cy="201168"/>
+          </a:xfrm>
+          <a:prstGeom prst="rect">
+            <a:avLst/>
+          </a:prstGeom>
+          <a:noFill/>
+        </p:spPr>
+        <p:txBody>
+          <a:bodyPr wrap="none" lIns="0" tIns="0" rIns="0" bIns="0" anchor="ctr"/>
+          <a:lstStyle/>
+          <a:p>
+            <a:pPr algn="l"/>
+            <a:r>
+              <a:rPr lang="en-US" sz="900">
+                <a:solidFill>
+                  <a:srgbClr val="8A8A8A"/>
+                </a:solidFill>
+                <a:latin typeface="Arial"/>
+                <a:cs typeface="Arial"/>
+              </a:rPr>
+              <a:t>Expert</a:t>
+            </a:r>
+          </a:p>
+        </p:txBody>
+      </p:sp>
+    </p:spTree>
+  </p:cSld>
+  <p:clrMapOvr>
+    <a:masterClrMapping/>
+  </p:clrMapOvr>
+  <p:transition xmlns:p14="http://schemas.microsoft.com/office/powerpoint/2010/main" spd="med" advClick="1"/>
+</p:sld>
+</file>
+
 <file path=ppt/slides/slide2.xml><?xml version="1.0" encoding="utf-8"?>
 <p:sld xmlns:a="http://schemas.openxmlformats.org/drawingml/2006/main" xmlns:r="http://schemas.openxmlformats.org/officeDocument/2006/relationships" xmlns:p="http://schemas.openxmlformats.org/presentationml/2006/main" xmlns:m="http://schemas.openxmlformats.org/officeDocument/2006/math" xmlns:a14="http://schemas.microsoft.com/office/drawing/2010/main" showMasterSp="1" showMasterPhAnim="1">
   <p:cSld>

</xml_diff>

<commit_message>
Lead with the copy rule and teach when a rule isn't needed
Co-authored-by: Cursor <cursoragent@cursor.com>
</commit_message>
<xml_diff>
--- a/snowtooth-rules.pptx
+++ b/snowtooth-rules.pptx
@@ -646,25 +646,25 @@
           <a:p>
             <a:pPr/>
             <a:r>
-              <a:t>This is the last stop, and it's how I know the session worked. Everyone writes one rule on their own, for something they've had to tell an agent twice at work or something in Snowtooth, and pastes it into chat.</a:t>
-            </a:r>
-          </a:p>
-          <a:p>
-            <a:pPr/>
-          </a:p>
-          <a:p>
-            <a:pPr/>
-            <a:r>
-              <a:t>If anyone's stuck: every time a guest sees should use formatMountainTime() from lib/time.ts, and nothing enforces that yet. The grooming prompt on the slide shows whether their rule works.</a:t>
-            </a:r>
-          </a:p>
-          <a:p>
-            <a:pPr/>
-          </a:p>
-          <a:p>
-            <a:pPr/>
-            <a:r>
-              <a:t>If the rules people post have a description, a do and a don't, and a pointer to a real file, they can do this without me. I read a couple out loud before we wrap up.</a:t>
+              <a:t>This is the last stop, and it's how I know the session worked. Everyone writes one rule on their own, for something the code doesn't already say, and pastes it into chat.</a:t>
+            </a:r>
+          </a:p>
+          <a:p>
+            <a:pPr/>
+          </a:p>
+          <a:p>
+            <a:pPr/>
+            <a:r>
+              <a:t>If anyone's stuck: guests read difficulty from the trail map symbols, green circle, blue square, black diamond, double black diamond, never the words. The prompt on the slide shows the miss. The complete branch has one possible answer.</a:t>
+            </a:r>
+          </a:p>
+          <a:p>
+            <a:pPr/>
+          </a:p>
+          <a:p>
+            <a:pPr/>
+            <a:r>
+              <a:t>If the rules people post have a description, a do and a don't, and a pointer to a real file, they can do this without me. If they picked something the code couldn't have told the agent, they understood when to reach for a rule.</a:t>
             </a:r>
           </a:p>
         </p:txBody>
@@ -822,7 +822,7 @@
           <a:p>
             <a:pPr/>
             <a:r>
-              <a:t>Paste the clone command and the handout link into chat right away. The repo is the only thing they need for the hands-on part.</a:t>
+              <a:t>Paste the clone command and the full handout into chat right away. The handout isn't in the repo: when it was, the agent read it and gave away the answers.</a:t>
             </a:r>
           </a:p>
           <a:p>
@@ -849,7 +849,7 @@
           <a:p>
             <a:pPr/>
             <a:r>
-              <a:t>If someone can't clone, they watch my screen for Part 1 and do the handout later. I don't hold up the room for it.</a:t>
+              <a:t>If someone can't clone, they watch my screen and do the handout later. I don't hold up the room for it.</a:t>
             </a:r>
           </a:p>
         </p:txBody>
@@ -937,7 +937,7 @@
           <a:p>
             <a:pPr/>
             <a:r>
-              <a:t>LiftBoard still calls fetch directly, on purpose. It's leftover code, and the agent will copy it. I'm not fixing it in this session, because rules are about what the agent writes next.</a:t>
+              <a:t>The conventions that bite are the ones that live in people's heads. The agent reads code, so anything the code already shows, it usually gets right. What guests call things isn't in any file.</a:t>
             </a:r>
           </a:p>
           <a:p>
@@ -1025,7 +1025,7 @@
           <a:p>
             <a:pPr/>
             <a:r>
-              <a:t>Three is about all 15 minutes can hold when a live agent is involved.</a:t>
+              <a:t>Spot it has two halves. You've corrected it more than once, and it's something the code can't show the agent. If the code already shows it, the agent usually gets it right without a rule.</a:t>
             </a:r>
           </a:p>
           <a:p>
@@ -1113,43 +1113,34 @@
           <a:p>
             <a:pPr/>
             <a:r>
-              <a:t>We're on main, in a new Agent chat, using the exact prompt on the slide. Everyone sends it in their own Cursor at the same time. Then I ask who got fetch and who got getTrails(). Expect a mix.</a:t>
-            </a:r>
-          </a:p>
-          <a:p>
-            <a:pPr/>
-          </a:p>
-          <a:p>
-            <a:pPr/>
-            <a:r>
-              <a:t>LiftBoard still calls the public API directly and styles status by hand. I left that in on purpose so the agent has a bad example to copy. StatusBadge and getTrails() already exist; the model just doesn't know the team expects it to use them.</a:t>
-            </a:r>
-          </a:p>
-          <a:p>
-            <a:pPr/>
-          </a:p>
-          <a:p>
-            <a:pPr/>
-            <a:r>
-              <a:t>If my agent uses the client anyway, I try the backup prompt: 'Add a night-skiing trails list.' If that works too, I say so: sometimes the model guesses right, and the rule is how we stop relying on guesses.</a:t>
-            </a:r>
-          </a:p>
-          <a:p>
-            <a:pPr/>
-          </a:p>
-          <a:p>
-            <a:pPr/>
-            <a:r>
-              <a:t>The miss comes first because a clean success doesn't teach much. Seeing the before and after is what makes it stick.</a:t>
-            </a:r>
-          </a:p>
-          <a:p>
-            <a:pPr/>
-          </a:p>
-          <a:p>
-            <a:pPr/>
-            <a:r>
-              <a:t>Then we undo it with Restore Checkpoint (Cursor's undo button, not git checkout) and write the rule.</a:t>
+              <a:t>We're on main, in a new Agent chat, using the exact prompt on the slide. Everyone sends it in their own Cursor at the same time, and we read the diff in two passes.</a:t>
+            </a:r>
+          </a:p>
+          <a:p>
+            <a:pPr/>
+          </a:p>
+          <a:p>
+            <a:pPr/>
+            <a:r>
+              <a:t>First, the data. It almost always calls getTrails(). I open lib/snowtooth.ts and point at the comment on top: the code already says how data works, so the agent followed it. We don't need a rule for that.</a:t>
+            </a:r>
+          </a:p>
+          <a:p>
+            <a:pPr/>
+          </a:p>
+          <a:p>
+            <a:pPr/>
+            <a:r>
+              <a:t>Second, the words. The heading says Trails, and the status is often a hand-styled span. I ask: where in this repo could the agent have learned that guests say runs? Nowhere. That's what a rule is for.</a:t>
+            </a:r>
+          </a:p>
+          <a:p>
+            <a:pPr/>
+          </a:p>
+          <a:p>
+            <a:pPr/>
+            <a:r>
+              <a:t>This is the core idea: a rule is for what the code can't tell the agent. If someone's agent used fetch anyway, that's a good catch, and a fine pick for the challenge.</a:t>
             </a:r>
           </a:p>
         </p:txBody>
@@ -1228,25 +1219,25 @@
           <a:p>
             <a:pPr/>
             <a:r>
-              <a:t>The description tells the agent when the rule applies. The do and don't are written as real code. And we point at @lib/snowtooth.ts instead of pasting the client in, because pasted copies go stale. That last part is a Cursor best practice, not just my preference. An @ reference isn't pasted into the prompt: the agent reads the file only when it decides it needs to. So anything that must always apply goes in the rule's own text, which is why the do and don't are written out and @lib/snowtooth.ts is only a pointer.</a:t>
-            </a:r>
-          </a:p>
-          <a:p>
-            <a:pPr/>
-          </a:p>
-          <a:p>
-            <a:pPr/>
-            <a:r>
-              <a:t>For the live session I use alwaysApply: true so the rule definitely fires in the next two minutes. At work, letting Cursor decide is usually the better default, but I don't want a 15-minute session to depend on the model making that call. I come back to this tradeoff on the last slide.</a:t>
-            </a:r>
-          </a:p>
-          <a:p>
-            <a:pPr/>
-          </a:p>
-          <a:p>
-            <a:pPr/>
-            <a:r>
-              <a:t>Cursor's docs recommend keeping each rule small and focused: one convention per rule, under 500 lines. That's why the data rule and the copy rule are separate files. In a 45-minute version I'd talk more about how to split rules up.</a:t>
+              <a:t>The description tells the agent when the rule applies. The do and don't are written as real code. And we point at @components/StatusBadge.tsx instead of pasting it in, because pasted copies go stale. An @ reference isn't pasted into the prompt: the agent reads the file only when it decides it needs to. So anything that must always apply goes in the rule's own text.</a:t>
+            </a:r>
+          </a:p>
+          <a:p>
+            <a:pPr/>
+          </a:p>
+          <a:p>
+            <a:pPr/>
+            <a:r>
+              <a:t>For the live session I use alwaysApply: true so the rule definitely fires in the next two minutes. At work, letting Cursor decide is usually the better default, but I don't want a 15-minute session to depend on the model making that call.</a:t>
+            </a:r>
+          </a:p>
+          <a:p>
+            <a:pPr/>
+          </a:p>
+          <a:p>
+            <a:pPr/>
+            <a:r>
+              <a:t>Cursor's docs recommend keeping each rule small and focused: one convention per rule, under 500 lines.</a:t>
             </a:r>
           </a:p>
         </p:txBody>
@@ -1316,7 +1307,7 @@
           <a:p>
             <a:pPr/>
             <a:r>
-              <a:t>Same prompt, new chat. This time it should call getTrails(). I point at the rule pill so people can see why: the rule was included this time. It has nothing to do with the last chat remembering anything.</a:t>
+              <a:t>Same prompt, new chat. This time the heading should say Open Runs and the status should use StatusBadge. The rule was included this time. It has nothing to do with the last chat remembering anything.</a:t>
             </a:r>
           </a:p>
           <a:p>
@@ -1334,25 +1325,7 @@
           <a:p>
             <a:pPr/>
             <a:r>
-              <a:t>If it doesn't work, I check the pill, confirm alwaysApply is set, and try one more new chat. If it still fails, I switch to the checkpoint branch and play the 90-second recording.</a:t>
-            </a:r>
-          </a:p>
-          <a:p>
-            <a:pPr/>
-          </a:p>
-          <a:p>
-            <a:pPr/>
-            <a:r>
-              <a:t>While I'm doing it, I mention that Restore Checkpoint is how you undo the first panel. Don't use git checkout during the demo unless the agent goes completely off the rails.</a:t>
-            </a:r>
-          </a:p>
-          <a:p>
-            <a:pPr/>
-          </a:p>
-          <a:p>
-            <a:pPr/>
-            <a:r>
-              <a:t>I skip the grooming report. The trails panel tells the whole story.</a:t>
+              <a:t>If it doesn't work, I check that the file ends in .mdc, confirm alwaysApply is set, and try one more new chat. If it still fails, I switch to the checkpoint branch and play the 90-second recording.</a:t>
             </a:r>
           </a:p>
         </p:txBody>
@@ -1422,25 +1395,25 @@
           <a:p>
             <a:pPr/>
             <a:r>
-              <a:t>It's the same loop, but this time it's about wording instead of data, and people do it themselves. Before anyone writes the rule, the room tells me what the do and don't should be, and I type that into chat so anyone who's behind can copy it.</a:t>
-            </a:r>
-          </a:p>
-          <a:p>
-            <a:pPr/>
-          </a:p>
-          <a:p>
-            <a:pPr/>
-            <a:r>
-              <a:t>I count the skis in chat to see how it's going. I'd like most of the room there by the 11-minute mark. If we're running late, I stop once they've named the convention, and the handout covers the rest.</a:t>
-            </a:r>
-          </a:p>
-          <a:p>
-            <a:pPr/>
-          </a:p>
-          <a:p>
-            <a:pPr/>
-            <a:r>
-              <a:t>handout.md is in .cursorignore so the agent can't read the answers. The extra credit exercises are in the handout for after the session.</a:t>
+              <a:t>I do each step on my screen first, then give the room a few seconds.</a:t>
+            </a:r>
+          </a:p>
+          <a:p>
+            <a:pPr/>
+          </a:p>
+          <a:p>
+            <a:pPr/>
+            <a:r>
+              <a:t>git stash -u resets everyone the same way. The next chat has to start from a clean folder, or it will copy the panel the last chat left behind. Restore Checkpoint also works, but it only shows up when you hover over an earlier message, and people lose minutes hunting for it on a call.</a:t>
+            </a:r>
+          </a:p>
+          <a:p>
+            <a:pPr/>
+          </a:p>
+          <a:p>
+            <a:pPr/>
+            <a:r>
+              <a:t>I count the skis in chat to see how it's going. Anyone who's behind runs git stash -u &amp;&amp; git checkout checkpoint and goes straight to the challenge.</a:t>
             </a:r>
           </a:p>
         </p:txBody>
@@ -1519,7 +1492,16 @@
           <a:p>
             <a:pPr/>
             <a:r>
-              <a:t>I go through the table quickly, but I slow down on security: a rule is guidance for the AI, not a security control. The Tab line comes from the docs. Rules don't apply to Tab or Cmd+K, so if completions still say trails, the rule isn't broken.</a:t>
+              <a:t>The new first row ties back to Part 1: the data client didn't need a rule, because lib/snowtooth.ts explains itself. Rules are for what the code can't say.</a:t>
+            </a:r>
+          </a:p>
+          <a:p>
+            <a:pPr/>
+          </a:p>
+          <a:p>
+            <a:pPr/>
+            <a:r>
+              <a:t>I go through the rest quickly, but I slow down on security: a rule is guidance for the AI, not a security control. Rules don't apply to Tab or Cmd+K, so if completions still say trails, the rule isn't broken.</a:t>
             </a:r>
           </a:p>
           <a:p>
@@ -3556,7 +3538,7 @@
           <a:p>
             <a:pPr/>
             <a:r>
-              <a:t>Pick something you've told an agent twice, at work or in Snowtooth.</a:t>
+              <a:t>Pick something the code doesn't already say, at work or in Snowtooth.</a:t>
             </a:r>
           </a:p>
         </p:txBody>
@@ -3768,7 +3750,7 @@
                 <a:latin typeface="Courier New"/>
                 <a:cs typeface="Courier New"/>
               </a:rPr>
-              <a:t>Stuck? Make every time a guest sees use formatMountainTime().</a:t>
+              <a:t>Stuck? Guests read difficulty from trail map symbols, never words.</a:t>
             </a:r>
           </a:p>
           <a:p>
@@ -3780,7 +3762,7 @@
                 <a:latin typeface="Courier New"/>
                 <a:cs typeface="Courier New"/>
               </a:rPr>
-              <a:t>Test it: “Add a panel that shows when each run was last groomed.”</a:t>
+              <a:t>Test it: “Add a panel that lists every run and its difficulty.”</a:t>
             </a:r>
           </a:p>
         </p:txBody>
@@ -5478,7 +5460,7 @@
           <a:p>
             <a:pPr/>
             <a:r>
-              <a:t>Open workshop/handout.md. We'll follow it together.</a:t>
+              <a:t>Open the handout from chat. We'll follow it together.</a:t>
             </a:r>
           </a:p>
         </p:txBody>
@@ -5711,7 +5693,7 @@
           <a:p>
             <a:pPr/>
             <a:r>
-              <a:t>“Remember, we don't fetch in components. Use the data client.”</a:t>
+              <a:t>“Remember, guests call them runs, not trails.”</a:t>
             </a:r>
           </a:p>
         </p:txBody>
@@ -5945,7 +5927,7 @@
           <a:p>
             <a:pPr/>
             <a:r>
-              <a:t>Tomorrow, Alex's agent still writes the raw fetch.</a:t>
+              <a:t>Tomorrow, Alex's agent still writes “Trails.”</a:t>
             </a:r>
           </a:p>
         </p:txBody>
@@ -6018,7 +6000,7 @@
           <a:p>
             <a:pPr/>
             <a:r>
-              <a:t>Agent copies leftovers</a:t>
+              <a:t>The code can't say it</a:t>
             </a:r>
           </a:p>
         </p:txBody>
@@ -6062,7 +6044,7 @@
           <a:p>
             <a:pPr/>
             <a:r>
-              <a:t>LiftBoard fetches, so the next panel will too.</a:t>
+              <a:t>No file in the repo says what guests call a run.</a:t>
             </a:r>
           </a:p>
         </p:txBody>
@@ -6312,7 +6294,7 @@
           <a:p>
             <a:pPr/>
             <a:r>
-              <a:t>Made the same correction twice? You need a rule, not a better prompt.</a:t>
+              <a:t>Corrected it twice, and the code can't show it? You need a rule.</a:t>
             </a:r>
           </a:p>
         </p:txBody>
@@ -6727,7 +6709,7 @@
           <a:p>
             <a:pPr/>
             <a:r>
-              <a:t>Without a rule, it copies what's there</a:t>
+              <a:t>It knows what the code tells it</a:t>
             </a:r>
           </a:p>
         </p:txBody>
@@ -6848,7 +6830,7 @@
           <a:p>
             <a:pPr/>
             <a:r>
-              <a:t>Add a panel that lists every trail and its difficulty.</a:t>
+              <a:t>Add a panel that lists the trails that are open right now, with each one's status.</a:t>
             </a:r>
           </a:p>
         </p:txBody>
@@ -6892,7 +6874,7 @@
           <a:p>
             <a:pPr/>
             <a:r>
-              <a:t>Send it in your own chat, then compare diffs.</a:t>
+              <a:t>Send it in your own chat, then read the diff.</a:t>
             </a:r>
           </a:p>
         </p:txBody>
@@ -6969,7 +6951,7 @@
           <a:p>
             <a:pPr/>
             <a:r>
-              <a:t>WHAT IT USUALLY COPIES</a:t>
+              <a:t>WHAT YOU'LL SEE</a:t>
             </a:r>
           </a:p>
         </p:txBody>
@@ -7017,7 +6999,7 @@
           <a:p>
             <a:pPr/>
             <a:r>
-              <a:t>fetch(…/lifts)</a:t>
+              <a:t>getTrails()</a:t>
             </a:r>
           </a:p>
         </p:txBody>
@@ -7061,7 +7043,7 @@
           <a:p>
             <a:pPr/>
             <a:r>
-              <a:t>LiftBoard still does this</a:t>
+              <a:t>Right: lib/snowtooth.ts says how</a:t>
             </a:r>
           </a:p>
         </p:txBody>
@@ -7109,7 +7091,7 @@
           <a:p>
             <a:pPr/>
             <a:r>
-              <a:t>No getTrails()</a:t>
+              <a:t>&lt;h2&gt;Trails&lt;/h2&gt;</a:t>
             </a:r>
           </a:p>
         </p:txBody>
@@ -7153,7 +7135,7 @@
           <a:p>
             <a:pPr/>
             <a:r>
-              <a:t>The client already exists</a:t>
+              <a:t>Wrong: nothing says “runs”</a:t>
             </a:r>
           </a:p>
         </p:txBody>
@@ -7429,7 +7411,7 @@
                   <a:schemeClr val="accent1"/>
                 </a:solidFill>
               </a:rPr>
-              <a:t>How to load Snowtooth data</a:t>
+              <a:t>Words guests see on the board</a:t>
             </a:r>
             <a:endParaRPr>
               <a:solidFill>
@@ -7513,7 +7495,7 @@
                   <a:schemeClr val="accent1"/>
                 </a:solidFill>
               </a:rPr>
-              <a:t>All data comes from @/lib/snowtooth.</a:t>
+              <a:t>Guests call them runs, never trails.</a:t>
             </a:r>
             <a:endParaRPr>
               <a:solidFill>
@@ -7539,7 +7521,7 @@
                   <a:schemeClr val="accent1"/>
                 </a:solidFill>
               </a:rPr>
-              <a:t>Never fetch in a component.</a:t>
+              <a:t>Every status uses &lt;StatusBadge&gt;.</a:t>
             </a:r>
             <a:endParaRPr>
               <a:solidFill>
@@ -7586,7 +7568,7 @@
                   <a:schemeClr val="accent1"/>
                 </a:solidFill>
               </a:rPr>
-              <a:t>await getTrails()</a:t>
+              <a:t>&lt;h2&gt;Open Runs&lt;/h2&gt;</a:t>
             </a:r>
             <a:endParaRPr>
               <a:solidFill>
@@ -7615,7 +7597,7 @@
                   <a:schemeClr val="accent1"/>
                 </a:solidFill>
               </a:rPr>
-              <a:t>fetch(".../lifts")</a:t>
+              <a:t>&lt;h2&gt;Open Trails&lt;/h2&gt;</a:t>
             </a:r>
             <a:endParaRPr>
               <a:solidFill>
@@ -7654,7 +7636,7 @@
               </a:defRPr>
             </a:pPr>
             <a:r>
-              <a:t>See @lib/snowtooth.ts</a:t>
+              <a:t>See @components/StatusBadge.tsx</a:t>
             </a:r>
           </a:p>
         </p:txBody>
@@ -8359,7 +8341,7 @@
           <a:p>
             <a:pPr/>
             <a:r>
-              <a:t>fetch(".../lifts")</a:t>
+              <a:t>&lt;h2&gt;Open Trails&lt;/h2&gt;</a:t>
             </a:r>
           </a:p>
         </p:txBody>
@@ -8528,7 +8510,7 @@
           <a:p>
             <a:pPr/>
             <a:r>
-              <a:t>await getTrails()</a:t>
+              <a:t>&lt;h2&gt;Open Runs&lt;/h2&gt;</a:t>
             </a:r>
           </a:p>
         </p:txBody>
@@ -8657,7 +8639,7 @@
           <a:p>
             <a:pPr/>
             <a:r>
-              <a:t>Your turn: the copy rule</a:t>
+              <a:t>Write the rule together</a:t>
             </a:r>
           </a:p>
         </p:txBody>
@@ -8822,7 +8804,7 @@
           <a:p>
             <a:pPr/>
             <a:r>
-              <a:t>New chat. Send the open-trails prompt from Part 2 of the handout.</a:t>
+              <a:t>Run git stash -u to throw away the agent's changes.</a:t>
             </a:r>
           </a:p>
         </p:txBody>
@@ -8914,7 +8896,7 @@
           <a:p>
             <a:pPr/>
             <a:r>
-              <a:t>Name the do and don't. Write the rule with /create-rule.</a:t>
+              <a:t>New chat. Type /create-rule and paste the prompt from the handout.</a:t>
             </a:r>
           </a:p>
         </p:txBody>
@@ -9164,7 +9146,7 @@
           <a:p>
             <a:pPr/>
             <a:r>
-              <a:t>You've had to say it twice</a:t>
+              <a:t>The code already shows it</a:t>
             </a:r>
           </a:p>
         </p:txBody>
@@ -9208,7 +9190,7 @@
           <a:p>
             <a:pPr/>
             <a:r>
-              <a:t>Write a rule</a:t>
+              <a:t>Skip the rule. The agent reads code.</a:t>
             </a:r>
           </a:p>
         </p:txBody>
@@ -9252,7 +9234,7 @@
           <a:p>
             <a:pPr/>
             <a:r>
-              <a:t>A linter or test could check it</a:t>
+              <a:t>You've had to say it twice</a:t>
             </a:r>
           </a:p>
         </p:txBody>
@@ -9296,7 +9278,7 @@
           <a:p>
             <a:pPr/>
             <a:r>
-              <a:t>Use the linter or test instead</a:t>
+              <a:t>Write a rule</a:t>
             </a:r>
           </a:p>
         </p:txBody>
@@ -9369,7 +9351,7 @@
           <a:p>
             <a:pPr/>
             <a:r>
-              <a:t>It only applies to some files</a:t>
+              <a:t>A linter or test could check it</a:t>
             </a:r>
           </a:p>
         </p:txBody>
@@ -9413,7 +9395,7 @@
           <a:p>
             <a:pPr/>
             <a:r>
-              <a:t>Add globs</a:t>
+              <a:t>Use the linter or test instead</a:t>
             </a:r>
           </a:p>
         </p:txBody>
@@ -9457,7 +9439,7 @@
           <a:p>
             <a:pPr/>
             <a:r>
-              <a:t>It should always be on</a:t>
+              <a:t>It only applies to some files</a:t>
             </a:r>
           </a:p>
         </p:txBody>
@@ -9501,7 +9483,7 @@
           <a:p>
             <a:pPr/>
             <a:r>
-              <a:t>Set alwaysApply: true</a:t>
+              <a:t>Add globs</a:t>
             </a:r>
           </a:p>
         </p:txBody>
@@ -9574,7 +9556,7 @@
           <a:p>
             <a:pPr/>
             <a:r>
-              <a:t>It's about security</a:t>
+              <a:t>It should always be on</a:t>
             </a:r>
           </a:p>
         </p:txBody>
@@ -9618,6 +9600,94 @@
           <a:p>
             <a:pPr/>
             <a:r>
+              <a:t>Set alwaysApply: true</a:t>
+            </a:r>
+          </a:p>
+        </p:txBody>
+      </p:sp>
+      <p:sp>
+        <p:nvSpPr>
+          <p:cNvPr id="168" name="if-6"/>
+          <p:cNvSpPr txBox="1"/>
+          <p:nvPr/>
+        </p:nvSpPr>
+        <p:spPr>
+          <a:xfrm>
+            <a:off x="621791" y="3223582"/>
+            <a:ext cx="4114801" cy="209668"/>
+          </a:xfrm>
+          <a:prstGeom prst="rect">
+            <a:avLst/>
+          </a:prstGeom>
+          <a:ln w="12700">
+            <a:miter lim="400000"/>
+          </a:ln>
+          <a:extLst>
+            <a:ext uri="{C572A759-6A51-4108-AA02-DFA0A04FC94B}">
+              <ma14:wrappingTextBoxFlag xmlns:ma14="http://schemas.microsoft.com/office/mac/drawingml/2011/main" val="1"/>
+            </a:ext>
+          </a:extLst>
+        </p:spPr>
+        <p:txBody>
+          <a:bodyPr lIns="0" tIns="0" rIns="0" bIns="0" anchor="ctr">
+            <a:spAutoFit/>
+          </a:bodyPr>
+          <a:lstStyle>
+            <a:lvl1pPr>
+              <a:defRPr sz="1500">
+                <a:solidFill>
+                  <a:schemeClr val="accent2"/>
+                </a:solidFill>
+              </a:defRPr>
+            </a:lvl1pPr>
+          </a:lstStyle>
+          <a:p>
+            <a:pPr/>
+            <a:r>
+              <a:t>It's about security</a:t>
+            </a:r>
+          </a:p>
+        </p:txBody>
+      </p:sp>
+      <p:sp>
+        <p:nvSpPr>
+          <p:cNvPr id="169" name="then-6"/>
+          <p:cNvSpPr txBox="1"/>
+          <p:nvPr/>
+        </p:nvSpPr>
+        <p:spPr>
+          <a:xfrm>
+            <a:off x="4846320" y="3223582"/>
+            <a:ext cx="3657601" cy="209668"/>
+          </a:xfrm>
+          <a:prstGeom prst="rect">
+            <a:avLst/>
+          </a:prstGeom>
+          <a:ln w="12700">
+            <a:miter lim="400000"/>
+          </a:ln>
+          <a:extLst>
+            <a:ext uri="{C572A759-6A51-4108-AA02-DFA0A04FC94B}">
+              <ma14:wrappingTextBoxFlag xmlns:ma14="http://schemas.microsoft.com/office/mac/drawingml/2011/main" val="1"/>
+            </a:ext>
+          </a:extLst>
+        </p:spPr>
+        <p:txBody>
+          <a:bodyPr lIns="0" tIns="0" rIns="0" bIns="0" anchor="ctr">
+            <a:spAutoFit/>
+          </a:bodyPr>
+          <a:lstStyle>
+            <a:lvl1pPr>
+              <a:defRPr sz="1500">
+                <a:solidFill>
+                  <a:schemeClr val="accent1"/>
+                </a:solidFill>
+              </a:defRPr>
+            </a:lvl1pPr>
+          </a:lstStyle>
+          <a:p>
+            <a:pPr/>
+            <a:r>
               <a:t>Don't rely on a rule alone</a:t>
             </a:r>
           </a:p>
@@ -9631,7 +9701,7 @@
         </p:nvSpPr>
         <p:spPr>
           <a:xfrm>
-            <a:off x="457200" y="3294380"/>
+            <a:off x="457200" y="3733292"/>
             <a:ext cx="8229600" cy="177801"/>
           </a:xfrm>
           <a:prstGeom prst="rect">

</xml_diff>